<commit_message>
Mark antenna port depth on dS-vs-depth; show S-params in dB
sim_dS_vs_depth.png: add antenna patch/port plane (z=+3mm) and measured-tumor
depth (z=+40mm) markers from HFSS geometry; fix peak label (|dS| max ~15mm is
the 4-antenna combined-sensitivity maximum, not "nearest antennas" -- patch is
at +3mm). sim_meas_correlation.png: S11 panel now in dB. Deck2/Deck3 text
updated to match; both decks rebuilt.

Co-Authored-By: Claude Opus 4.8 <noreply@anthropic.com>
</commit_message>
<xml_diff>
--- a/regression_deck/Deck2_Simulated_Regression.pptx
+++ b/regression_deck/Deck2_Simulated_Regression.pptx
@@ -2836,7 +2836,7 @@
                 <a:ea typeface="Calibri" pitchFamily="34" charset="-122"/>
                 <a:cs typeface="Calibri" pitchFamily="34" charset="-120"/>
               </a:rPr>
-              <a:t>13 tumor heights — the perturbation peaks near the antenna plane and fades with distance</a:t>
+              <a:t>13 tumor heights — the perturbation peaks mid-phantom and fades with distance</a:t>
             </a:r>
             <a:endParaRPr lang="en-US" sz="1400" dirty="0"/>
           </a:p>
@@ -2968,7 +2968,7 @@
               <a:buChar char="•"/>
             </a:pPr>
             <a:r>
-              <a:rPr lang="en-US" sz="1250" dirty="0">
+              <a:rPr lang="en-US" sz="1200" dirty="0">
                 <a:solidFill>
                   <a:srgbClr val="1E293B"/>
                 </a:solidFill>
@@ -2978,7 +2978,7 @@
               </a:rPr>
               <a:t>ΔS = tumor − empty, averaged over frequency and all 16 S-parameters.</a:t>
             </a:r>
-            <a:endParaRPr lang="en-US" sz="1250" dirty="0"/>
+            <a:endParaRPr lang="en-US" sz="1200" dirty="0"/>
           </a:p>
           <a:p>
             <a:pPr marL="342900" indent="-342900">
@@ -2989,7 +2989,7 @@
               <a:buChar char="•"/>
             </a:pPr>
             <a:r>
-              <a:rPr lang="en-US" sz="1250" dirty="0">
+              <a:rPr lang="en-US" sz="1200" dirty="0">
                 <a:solidFill>
                   <a:srgbClr val="1E293B"/>
                 </a:solidFill>
@@ -2997,9 +2997,9 @@
                 <a:ea typeface="Calibri" pitchFamily="34" charset="-122"/>
                 <a:cs typeface="Calibri" pitchFamily="34" charset="-120"/>
               </a:rPr>
-              <a:t>Strongest at z ≈ 15–20 mm — where the tumor is closest to the antenna plane.</a:t>
-            </a:r>
-            <a:endParaRPr lang="en-US" sz="1250" dirty="0"/>
+              <a:t>Antenna patch/port plane sits at z = +3 mm; the measured tumor sat at z = +40 mm.</a:t>
+            </a:r>
+            <a:endParaRPr lang="en-US" sz="1200" dirty="0"/>
           </a:p>
           <a:p>
             <a:pPr marL="342900" indent="-342900">
@@ -3010,7 +3010,7 @@
               <a:buChar char="•"/>
             </a:pPr>
             <a:r>
-              <a:rPr lang="en-US" sz="1250" dirty="0">
+              <a:rPr lang="en-US" sz="1200" dirty="0">
                 <a:solidFill>
                   <a:srgbClr val="1E293B"/>
                 </a:solidFill>
@@ -3018,9 +3018,9 @@
                 <a:ea typeface="Calibri" pitchFamily="34" charset="-122"/>
                 <a:cs typeface="Calibri" pitchFamily="34" charset="-120"/>
               </a:rPr>
-              <a:t>Falls off smoothly both ways; the far/edge depths carry the least signal.</a:t>
-            </a:r>
-            <a:endParaRPr lang="en-US" sz="1250" dirty="0"/>
+              <a:t>Combined 4-antenna sensitivity peaks ~15 mm into the phantom — not at the patch.</a:t>
+            </a:r>
+            <a:endParaRPr lang="en-US" sz="1200" dirty="0"/>
           </a:p>
           <a:p>
             <a:pPr marL="342900" indent="-342900">
@@ -3031,7 +3031,7 @@
               <a:buChar char="•"/>
             </a:pPr>
             <a:r>
-              <a:rPr lang="en-US" sz="1250" dirty="0">
+              <a:rPr lang="en-US" sz="1200" dirty="0">
                 <a:solidFill>
                   <a:srgbClr val="1E293B"/>
                 </a:solidFill>
@@ -3039,9 +3039,9 @@
                 <a:ea typeface="Calibri" pitchFamily="34" charset="-122"/>
                 <a:cs typeface="Calibri" pitchFamily="34" charset="-120"/>
               </a:rPr>
-              <a:t>This is exactly why localization degrades toward the depth extremes.</a:t>
-            </a:r>
-            <a:endParaRPr lang="en-US" sz="1250" dirty="0"/>
+              <a:t>Falls off smoothly both ways; far depths carry the least signal → localization degrades there.</a:t>
+            </a:r>
+            <a:endParaRPr lang="en-US" sz="1200" dirty="0"/>
           </a:p>
         </p:txBody>
       </p:sp>

</xml_diff>

<commit_message>
Distinguish antenna port/feed (+3mm) from radiating patch (~15-20mm)
Per feed-line geometry: the port/feed is at z=+3mm but the radiating patch sits
~15-20mm in, which is exactly where |dS| peaks (tumor nearest the radiator).
sim_dS_vs_depth.png marks port/feed, patch-radiator band, and measured depth
(+40mm). Deck2 text updated to match; deck rebuilt. CHANGELOG corrected.

Co-Authored-By: Claude Opus 4.8 <noreply@anthropic.com>
</commit_message>
<xml_diff>
--- a/regression_deck/Deck2_Simulated_Regression.pptx
+++ b/regression_deck/Deck2_Simulated_Regression.pptx
@@ -2836,7 +2836,7 @@
                 <a:ea typeface="Calibri" pitchFamily="34" charset="-122"/>
                 <a:cs typeface="Calibri" pitchFamily="34" charset="-120"/>
               </a:rPr>
-              <a:t>13 tumor heights — the perturbation peaks mid-phantom and fades with distance</a:t>
+              <a:t>13 tumor heights — the perturbation peaks at the radiating patch and fades with distance</a:t>
             </a:r>
             <a:endParaRPr lang="en-US" sz="1400" dirty="0"/>
           </a:p>
@@ -2997,7 +2997,7 @@
                 <a:ea typeface="Calibri" pitchFamily="34" charset="-122"/>
                 <a:cs typeface="Calibri" pitchFamily="34" charset="-120"/>
               </a:rPr>
-              <a:t>Antenna patch/port plane sits at z = +3 mm; the measured tumor sat at z = +40 mm.</a:t>
+              <a:t>Port/feed is at z = +3 mm, but the radiating patch sits ~15–20 mm in (feed-line offset).</a:t>
             </a:r>
             <a:endParaRPr lang="en-US" sz="1200" dirty="0"/>
           </a:p>
@@ -3018,7 +3018,7 @@
                 <a:ea typeface="Calibri" pitchFamily="34" charset="-122"/>
                 <a:cs typeface="Calibri" pitchFamily="34" charset="-120"/>
               </a:rPr>
-              <a:t>Combined 4-antenna sensitivity peaks ~15 mm into the phantom — not at the patch.</a:t>
+              <a:t>ΔS peaks right at the patch (~15–20 mm) — where the tumor is nearest the radiator.</a:t>
             </a:r>
             <a:endParaRPr lang="en-US" sz="1200" dirty="0"/>
           </a:p>
@@ -3039,7 +3039,7 @@
                 <a:ea typeface="Calibri" pitchFamily="34" charset="-122"/>
                 <a:cs typeface="Calibri" pitchFamily="34" charset="-120"/>
               </a:rPr>
-              <a:t>Falls off smoothly both ways; far depths carry the least signal → localization degrades there.</a:t>
+              <a:t>Falls off both ways; far depths carry the least signal → localization degrades there. (Measured tumor sat at z = +40 mm.)</a:t>
             </a:r>
             <a:endParaRPr lang="en-US" sz="1200" dirty="0"/>
           </a:p>

</xml_diff>

<commit_message>
Measured |dS| vs depth: bench confirms the sim depth shape
fig_measured_dS_vs_depth.py reads the 4 July10 depth sessions and computes mean
|dS| (tumor minus empty baseline) at each height: -20mm 0.0023, -7mm 0.0042,
+15mm 0.0053 (peak), +25mm 0.0044. Peaks at the radiating patch (+15mm) and
falls off both ways, same shape as the noiseless sim. New Deck 2 slide "The
bench sees the same depth shape".

Co-Authored-By: Claude Opus 4.8 <noreply@anthropic.com>
</commit_message>
<xml_diff>
--- a/regression_deck/Deck2_Simulated_Regression.pptx
+++ b/regression_deck/Deck2_Simulated_Regression.pptx
@@ -15,9 +15,10 @@
     <p:sldId id="263" r:id="rId9"/>
     <p:sldId id="264" r:id="rId10"/>
     <p:sldId id="265" r:id="rId11"/>
+    <p:sldId id="266" r:id="rId12"/>
   </p:sldIdLst>
   <p:notesMasterIdLst>
-    <p:notesMasterId r:id="rId12"/>
+    <p:notesMasterId r:id="rId13"/>
   </p:notesMasterIdLst>
   <p:sldSz cx="12188952" cy="6858000"/>
   <p:notesSz cx="6858000" cy="12188952"/>
@@ -623,6 +624,94 @@
             <a:fld id="{F7021451-1387-4CA6-816F-3879F97B5CBC}" type="slidenum">
               <a:rPr lang="en-US"/>
               <a:t>10</a:t>
+            </a:fld>
+            <a:endParaRPr lang="en-US"/>
+          </a:p>
+        </p:txBody>
+      </p:sp>
+    </p:spTree>
+    <p:extLst>
+      <p:ext uri="{BB962C8B-B14F-4D97-AF65-F5344CB8AC3E}">
+        <p14:creationId xmlns:p14="http://schemas.microsoft.com/office/powerpoint/2010/main" val="1024086991"/>
+      </p:ext>
+    </p:extLst>
+  </p:cSld>
+  <p:clrMapOvr>
+    <a:masterClrMapping/>
+  </p:clrMapOvr>
+</p:notes>
+</file>
+
+<file path=ppt/notesSlides/notesSlide11.xml><?xml version="1.0" encoding="utf-8"?>
+<p:notes xmlns:a="http://schemas.openxmlformats.org/drawingml/2006/main" xmlns:r="http://schemas.openxmlformats.org/officeDocument/2006/relationships" xmlns:p="http://schemas.openxmlformats.org/presentationml/2006/main">
+  <p:cSld>
+    <p:spTree>
+      <p:nvGrpSpPr>
+        <p:cNvPr id="1" name=""/>
+        <p:cNvGrpSpPr/>
+        <p:nvPr/>
+      </p:nvGrpSpPr>
+      <p:grpSpPr>
+        <a:xfrm>
+          <a:off x="0" y="0"/>
+          <a:ext cx="0" cy="0"/>
+          <a:chOff x="0" y="0"/>
+          <a:chExt cx="0" cy="0"/>
+        </a:xfrm>
+      </p:grpSpPr>
+      <p:sp>
+        <p:nvSpPr>
+          <p:cNvPr id="2" name="Slide Image Placeholder 1"/>
+          <p:cNvSpPr>
+            <a:spLocks noGrp="1" noRot="1" noChangeAspect="1"/>
+          </p:cNvSpPr>
+          <p:nvPr>
+            <p:ph type="sldImg"/>
+          </p:nvPr>
+        </p:nvSpPr>
+        <p:spPr/>
+      </p:sp>
+      <p:sp>
+        <p:nvSpPr>
+          <p:cNvPr id="3" name="Notes Placeholder 2"/>
+          <p:cNvSpPr>
+            <a:spLocks noGrp="1"/>
+          </p:cNvSpPr>
+          <p:nvPr>
+            <p:ph type="body" idx="1"/>
+          </p:nvPr>
+        </p:nvSpPr>
+        <p:spPr/>
+        <p:txBody>
+          <a:bodyPr/>
+          <a:lstStyle/>
+          <a:p>
+            <a:r>
+              <a:rPr lang="en-US" dirty="0"/>
+              <a:t/>
+            </a:r>
+            <a:endParaRPr lang="en-US" dirty="0"/>
+          </a:p>
+        </p:txBody>
+      </p:sp>
+      <p:sp>
+        <p:nvSpPr>
+          <p:cNvPr id="4" name="Slide Number Placeholder 3"/>
+          <p:cNvSpPr>
+            <a:spLocks noGrp="1"/>
+          </p:cNvSpPr>
+          <p:nvPr>
+            <p:ph type="sldNum" sz="quarter" idx="10"/>
+          </p:nvPr>
+        </p:nvSpPr>
+        <p:spPr/>
+        <p:txBody>
+          <a:bodyPr/>
+          <a:lstStyle/>
+          <a:p>
+            <a:fld id="{F7021451-1387-4CA6-816F-3879F97B5CBC}" type="slidenum">
+              <a:rPr lang="en-US"/>
+              <a:t>11</a:t>
             </a:fld>
             <a:endParaRPr lang="en-US"/>
           </a:p>
@@ -2081,6 +2170,446 @@
     <p:bg>
       <p:bgPr>
         <a:solidFill>
+          <a:srgbClr val="FFFFFF"/>
+        </a:solidFill>
+      </p:bgPr>
+    </p:bg>
+    <p:spTree>
+      <p:nvGrpSpPr>
+        <p:cNvPr id="1" name=""/>
+        <p:cNvGrpSpPr/>
+        <p:nvPr/>
+      </p:nvGrpSpPr>
+      <p:grpSpPr>
+        <a:xfrm>
+          <a:off x="0" y="0"/>
+          <a:ext cx="0" cy="0"/>
+          <a:chOff x="0" y="0"/>
+          <a:chExt cx="0" cy="0"/>
+        </a:xfrm>
+      </p:grpSpPr>
+      <p:sp>
+        <p:nvSpPr>
+          <p:cNvPr id="2" name="Text 0"/>
+          <p:cNvSpPr/>
+          <p:nvPr/>
+        </p:nvSpPr>
+        <p:spPr>
+          <a:xfrm>
+            <a:off x="548640" y="384048"/>
+            <a:ext cx="11091672" cy="640080"/>
+          </a:xfrm>
+          <a:prstGeom prst="rect">
+            <a:avLst/>
+          </a:prstGeom>
+          <a:noFill/>
+          <a:ln/>
+        </p:spPr>
+        <p:txBody>
+          <a:bodyPr wrap="square" lIns="0" tIns="0" rIns="0" bIns="0" rtlCol="0" anchor="ctr"/>
+          <a:lstStyle/>
+          <a:p>
+            <a:pPr indent="0" marL="0">
+              <a:buNone/>
+            </a:pPr>
+            <a:r>
+              <a:rPr lang="en-US" sz="2900" b="1" dirty="0">
+                <a:solidFill>
+                  <a:srgbClr val="2A1618"/>
+                </a:solidFill>
+                <a:latin typeface="Cambria" pitchFamily="34" charset="0"/>
+                <a:ea typeface="Cambria" pitchFamily="34" charset="-122"/>
+                <a:cs typeface="Cambria" pitchFamily="34" charset="-120"/>
+              </a:rPr>
+              <a:t>Predicted vs. actual, by depth</a:t>
+            </a:r>
+            <a:endParaRPr lang="en-US" sz="2900" dirty="0"/>
+          </a:p>
+        </p:txBody>
+      </p:sp>
+      <p:sp>
+        <p:nvSpPr>
+          <p:cNvPr id="3" name="Text 1"/>
+          <p:cNvSpPr/>
+          <p:nvPr/>
+        </p:nvSpPr>
+        <p:spPr>
+          <a:xfrm>
+            <a:off x="548640" y="1033272"/>
+            <a:ext cx="11091672" cy="365760"/>
+          </a:xfrm>
+          <a:prstGeom prst="rect">
+            <a:avLst/>
+          </a:prstGeom>
+          <a:noFill/>
+          <a:ln/>
+        </p:spPr>
+        <p:txBody>
+          <a:bodyPr wrap="square" lIns="0" tIns="0" rIns="0" bIns="0" rtlCol="0" anchor="ctr"/>
+          <a:lstStyle/>
+          <a:p>
+            <a:pPr indent="0" marL="0">
+              <a:buNone/>
+            </a:pPr>
+            <a:r>
+              <a:rPr lang="en-US" sz="1400" b="1" dirty="0">
+                <a:solidFill>
+                  <a:srgbClr val="BE0000"/>
+                </a:solidFill>
+                <a:latin typeface="Calibri" pitchFamily="34" charset="0"/>
+                <a:ea typeface="Calibri" pitchFamily="34" charset="-122"/>
+                <a:cs typeface="Calibri" pitchFamily="34" charset="-120"/>
+              </a:rPr>
+              <a:t>Arrows = lateral error, marker color = depth error, red ring = grid-edge position</a:t>
+            </a:r>
+            <a:endParaRPr lang="en-US" sz="1400" dirty="0"/>
+          </a:p>
+        </p:txBody>
+      </p:sp>
+      <p:sp>
+        <p:nvSpPr>
+          <p:cNvPr id="4" name="Shape 2"/>
+          <p:cNvSpPr/>
+          <p:nvPr/>
+        </p:nvSpPr>
+        <p:spPr>
+          <a:xfrm>
+            <a:off x="310896" y="1581912"/>
+            <a:ext cx="3794760" cy="3977640"/>
+          </a:xfrm>
+          <a:prstGeom prst="roundRect">
+            <a:avLst>
+              <a:gd name="adj" fmla="val 2169"/>
+            </a:avLst>
+          </a:prstGeom>
+          <a:solidFill>
+            <a:srgbClr val="FBF4F2"/>
+          </a:solidFill>
+          <a:ln w="12700">
+            <a:solidFill>
+              <a:srgbClr val="E7D6D1"/>
+            </a:solidFill>
+            <a:prstDash val="solid"/>
+          </a:ln>
+          <a:effectLst>
+            <a:outerShdw sx="100000" sy="100000" kx="0" ky="0" algn="bl" rotWithShape="0" blurRad="88900" dist="38100" dir="5400000">
+              <a:srgbClr val="7A5C5E">
+                <a:alpha val="18000"/>
+              </a:srgbClr>
+            </a:outerShdw>
+          </a:effectLst>
+        </p:spPr>
+      </p:sp>
+      <p:pic>
+        <p:nvPicPr>
+          <p:cNvPr id="5" name="Image 0" descr="sim_depth_examples/sim_depthplot_zp15_n25.png">    </p:cNvPr>
+          <p:cNvPicPr>
+            <a:picLocks noChangeAspect="1"/>
+          </p:cNvPicPr>
+          <p:nvPr/>
+        </p:nvPicPr>
+        <p:blipFill>
+          <a:blip r:embed="rId1"/>
+          <a:stretch>
+            <a:fillRect/>
+          </a:stretch>
+        </p:blipFill>
+        <p:spPr>
+          <a:xfrm>
+            <a:off x="402336" y="1691640"/>
+            <a:ext cx="3611880" cy="3429000"/>
+          </a:xfrm>
+          <a:prstGeom prst="rect">
+            <a:avLst/>
+          </a:prstGeom>
+        </p:spPr>
+      </p:pic>
+      <p:sp>
+        <p:nvSpPr>
+          <p:cNvPr id="6" name="Text 3"/>
+          <p:cNvSpPr/>
+          <p:nvPr/>
+        </p:nvSpPr>
+        <p:spPr>
+          <a:xfrm>
+            <a:off x="310896" y="5120640"/>
+            <a:ext cx="3794760" cy="329184"/>
+          </a:xfrm>
+          <a:prstGeom prst="rect">
+            <a:avLst/>
+          </a:prstGeom>
+          <a:noFill/>
+          <a:ln/>
+        </p:spPr>
+        <p:txBody>
+          <a:bodyPr wrap="square" lIns="0" tIns="0" rIns="0" bIns="0" rtlCol="0" anchor="ctr"/>
+          <a:lstStyle/>
+          <a:p>
+            <a:pPr algn="ctr" indent="0" marL="0">
+              <a:buNone/>
+            </a:pPr>
+            <a:r>
+              <a:rPr lang="en-US" sz="1300" b="1" dirty="0">
+                <a:solidFill>
+                  <a:srgbClr val="BE0000"/>
+                </a:solidFill>
+                <a:latin typeface="Calibri" pitchFamily="34" charset="0"/>
+                <a:ea typeface="Calibri" pitchFamily="34" charset="-122"/>
+                <a:cs typeface="Calibri" pitchFamily="34" charset="-120"/>
+              </a:rPr>
+              <a:t>z = +15 mm  (peak signal)</a:t>
+            </a:r>
+            <a:endParaRPr lang="en-US" sz="1300" dirty="0"/>
+          </a:p>
+        </p:txBody>
+      </p:sp>
+      <p:sp>
+        <p:nvSpPr>
+          <p:cNvPr id="7" name="Shape 4"/>
+          <p:cNvSpPr/>
+          <p:nvPr/>
+        </p:nvSpPr>
+        <p:spPr>
+          <a:xfrm>
+            <a:off x="4197096" y="1581912"/>
+            <a:ext cx="3794760" cy="3977640"/>
+          </a:xfrm>
+          <a:prstGeom prst="roundRect">
+            <a:avLst>
+              <a:gd name="adj" fmla="val 2169"/>
+            </a:avLst>
+          </a:prstGeom>
+          <a:solidFill>
+            <a:srgbClr val="FBF4F2"/>
+          </a:solidFill>
+          <a:ln w="12700">
+            <a:solidFill>
+              <a:srgbClr val="E7D6D1"/>
+            </a:solidFill>
+            <a:prstDash val="solid"/>
+          </a:ln>
+          <a:effectLst>
+            <a:outerShdw sx="100000" sy="100000" kx="0" ky="0" algn="bl" rotWithShape="0" blurRad="88900" dist="38100" dir="5400000">
+              <a:srgbClr val="7A5C5E">
+                <a:alpha val="18000"/>
+              </a:srgbClr>
+            </a:outerShdw>
+          </a:effectLst>
+        </p:spPr>
+      </p:sp>
+      <p:pic>
+        <p:nvPicPr>
+          <p:cNvPr id="8" name="Image 1" descr="sim_depth_examples/sim_depthplot_zp30_n25.png">    </p:cNvPr>
+          <p:cNvPicPr>
+            <a:picLocks noChangeAspect="1"/>
+          </p:cNvPicPr>
+          <p:nvPr/>
+        </p:nvPicPr>
+        <p:blipFill>
+          <a:blip r:embed="rId2"/>
+          <a:stretch>
+            <a:fillRect/>
+          </a:stretch>
+        </p:blipFill>
+        <p:spPr>
+          <a:xfrm>
+            <a:off x="4288536" y="1691640"/>
+            <a:ext cx="3611880" cy="3429000"/>
+          </a:xfrm>
+          <a:prstGeom prst="rect">
+            <a:avLst/>
+          </a:prstGeom>
+        </p:spPr>
+      </p:pic>
+      <p:sp>
+        <p:nvSpPr>
+          <p:cNvPr id="9" name="Text 5"/>
+          <p:cNvSpPr/>
+          <p:nvPr/>
+        </p:nvSpPr>
+        <p:spPr>
+          <a:xfrm>
+            <a:off x="4197096" y="5120640"/>
+            <a:ext cx="3794760" cy="329184"/>
+          </a:xfrm>
+          <a:prstGeom prst="rect">
+            <a:avLst/>
+          </a:prstGeom>
+          <a:noFill/>
+          <a:ln/>
+        </p:spPr>
+        <p:txBody>
+          <a:bodyPr wrap="square" lIns="0" tIns="0" rIns="0" bIns="0" rtlCol="0" anchor="ctr"/>
+          <a:lstStyle/>
+          <a:p>
+            <a:pPr algn="ctr" indent="0" marL="0">
+              <a:buNone/>
+            </a:pPr>
+            <a:r>
+              <a:rPr lang="en-US" sz="1300" b="1" dirty="0">
+                <a:solidFill>
+                  <a:srgbClr val="BE0000"/>
+                </a:solidFill>
+                <a:latin typeface="Calibri" pitchFamily="34" charset="0"/>
+                <a:ea typeface="Calibri" pitchFamily="34" charset="-122"/>
+                <a:cs typeface="Calibri" pitchFamily="34" charset="-120"/>
+              </a:rPr>
+              <a:t>z = +30 mm  (interior)</a:t>
+            </a:r>
+            <a:endParaRPr lang="en-US" sz="1300" dirty="0"/>
+          </a:p>
+        </p:txBody>
+      </p:sp>
+      <p:sp>
+        <p:nvSpPr>
+          <p:cNvPr id="10" name="Shape 6"/>
+          <p:cNvSpPr/>
+          <p:nvPr/>
+        </p:nvSpPr>
+        <p:spPr>
+          <a:xfrm>
+            <a:off x="8083296" y="1581912"/>
+            <a:ext cx="3794760" cy="3977640"/>
+          </a:xfrm>
+          <a:prstGeom prst="roundRect">
+            <a:avLst>
+              <a:gd name="adj" fmla="val 2169"/>
+            </a:avLst>
+          </a:prstGeom>
+          <a:solidFill>
+            <a:srgbClr val="FBF4F2"/>
+          </a:solidFill>
+          <a:ln w="12700">
+            <a:solidFill>
+              <a:srgbClr val="E7D6D1"/>
+            </a:solidFill>
+            <a:prstDash val="solid"/>
+          </a:ln>
+          <a:effectLst>
+            <a:outerShdw sx="100000" sy="100000" kx="0" ky="0" algn="bl" rotWithShape="0" blurRad="88900" dist="38100" dir="5400000">
+              <a:srgbClr val="7A5C5E">
+                <a:alpha val="18000"/>
+              </a:srgbClr>
+            </a:outerShdw>
+          </a:effectLst>
+        </p:spPr>
+      </p:sp>
+      <p:pic>
+        <p:nvPicPr>
+          <p:cNvPr id="11" name="Image 2" descr="sim_depth_examples/sim_depthplot_zp45_n25.png">    </p:cNvPr>
+          <p:cNvPicPr>
+            <a:picLocks noChangeAspect="1"/>
+          </p:cNvPicPr>
+          <p:nvPr/>
+        </p:nvPicPr>
+        <p:blipFill>
+          <a:blip r:embed="rId3"/>
+          <a:stretch>
+            <a:fillRect/>
+          </a:stretch>
+        </p:blipFill>
+        <p:spPr>
+          <a:xfrm>
+            <a:off x="8174736" y="1691640"/>
+            <a:ext cx="3611880" cy="3429000"/>
+          </a:xfrm>
+          <a:prstGeom prst="rect">
+            <a:avLst/>
+          </a:prstGeom>
+        </p:spPr>
+      </p:pic>
+      <p:sp>
+        <p:nvSpPr>
+          <p:cNvPr id="12" name="Text 7"/>
+          <p:cNvSpPr/>
+          <p:nvPr/>
+        </p:nvSpPr>
+        <p:spPr>
+          <a:xfrm>
+            <a:off x="8083296" y="5120640"/>
+            <a:ext cx="3794760" cy="329184"/>
+          </a:xfrm>
+          <a:prstGeom prst="rect">
+            <a:avLst/>
+          </a:prstGeom>
+          <a:noFill/>
+          <a:ln/>
+        </p:spPr>
+        <p:txBody>
+          <a:bodyPr wrap="square" lIns="0" tIns="0" rIns="0" bIns="0" rtlCol="0" anchor="ctr"/>
+          <a:lstStyle/>
+          <a:p>
+            <a:pPr algn="ctr" indent="0" marL="0">
+              <a:buNone/>
+            </a:pPr>
+            <a:r>
+              <a:rPr lang="en-US" sz="1300" b="1" dirty="0">
+                <a:solidFill>
+                  <a:srgbClr val="BE0000"/>
+                </a:solidFill>
+                <a:latin typeface="Calibri" pitchFamily="34" charset="0"/>
+                <a:ea typeface="Calibri" pitchFamily="34" charset="-122"/>
+                <a:cs typeface="Calibri" pitchFamily="34" charset="-120"/>
+              </a:rPr>
+              <a:t>z = +45 mm  (outer edge)</a:t>
+            </a:r>
+            <a:endParaRPr lang="en-US" sz="1300" dirty="0"/>
+          </a:p>
+        </p:txBody>
+      </p:sp>
+      <p:sp>
+        <p:nvSpPr>
+          <p:cNvPr id="13" name="Text 8"/>
+          <p:cNvSpPr/>
+          <p:nvPr/>
+        </p:nvSpPr>
+        <p:spPr>
+          <a:xfrm>
+            <a:off x="548640" y="6126480"/>
+            <a:ext cx="11091672" cy="457200"/>
+          </a:xfrm>
+          <a:prstGeom prst="rect">
+            <a:avLst/>
+          </a:prstGeom>
+          <a:noFill/>
+          <a:ln/>
+        </p:spPr>
+        <p:txBody>
+          <a:bodyPr wrap="square" lIns="0" tIns="0" rIns="0" bIns="0" rtlCol="0" anchor="ctr"/>
+          <a:lstStyle/>
+          <a:p>
+            <a:pPr algn="ctr" indent="0" marL="0">
+              <a:buNone/>
+            </a:pPr>
+            <a:r>
+              <a:rPr lang="en-US" sz="1300" i="1" dirty="0">
+                <a:solidFill>
+                  <a:srgbClr val="836A68"/>
+                </a:solidFill>
+                <a:latin typeface="Calibri" pitchFamily="34" charset="0"/>
+                <a:ea typeface="Calibri" pitchFamily="34" charset="-122"/>
+                <a:cs typeface="Calibri" pitchFamily="34" charset="-120"/>
+              </a:rPr>
+              <a:t>Interior depths (z=+15/+30) predict tightly; the +45 mm outer edge shows the extrapolation blow-up in both lateral arrows and depth color.</a:t>
+            </a:r>
+            <a:endParaRPr lang="en-US" sz="1300" dirty="0"/>
+          </a:p>
+        </p:txBody>
+      </p:sp>
+    </p:spTree>
+  </p:cSld>
+  <p:clrMapOvr>
+    <a:masterClrMapping/>
+  </p:clrMapOvr>
+</p:sld>
+</file>
+
+<file path=ppt/slides/slide11.xml><?xml version="1.0" encoding="utf-8"?>
+<p:sld xmlns:a="http://schemas.openxmlformats.org/drawingml/2006/main" xmlns:r="http://schemas.openxmlformats.org/officeDocument/2006/relationships" xmlns:p="http://schemas.openxmlformats.org/presentationml/2006/main">
+  <p:cSld name="Slide 11">
+    <p:bg>
+      <p:bgPr>
+        <a:solidFill>
           <a:srgbClr val="FDF8F6"/>
         </a:solidFill>
       </p:bgPr>
@@ -4272,7 +4801,7 @@
                 <a:ea typeface="Cambria" pitchFamily="34" charset="-122"/>
                 <a:cs typeface="Cambria" pitchFamily="34" charset="-120"/>
               </a:rPr>
-              <a:t>The 3D localization network</a:t>
+              <a:t>The bench sees the same depth shape</a:t>
             </a:r>
             <a:endParaRPr lang="en-US" sz="2900" dirty="0"/>
           </a:p>
@@ -4311,26 +4840,50 @@
                 <a:ea typeface="Calibri" pitchFamily="34" charset="-122"/>
                 <a:cs typeface="Calibri" pitchFamily="34" charset="-120"/>
               </a:rPr>
-              <a:t>Same architecture as the measured CNN, with one extra output for depth</a:t>
+              <a:t>Measured tumor perturbation across 4 heights, independent of the simulation</a:t>
             </a:r>
             <a:endParaRPr lang="en-US" sz="1400" dirty="0"/>
           </a:p>
         </p:txBody>
       </p:sp>
-      <p:sp>
-        <p:nvSpPr>
-          <p:cNvPr id="4" name="Shape 2"/>
-          <p:cNvSpPr/>
-          <p:nvPr/>
-        </p:nvSpPr>
-        <p:spPr>
-          <a:xfrm>
-            <a:off x="548640" y="1600200"/>
-            <a:ext cx="11091672" cy="1024128"/>
+      <p:pic>
+        <p:nvPicPr>
+          <p:cNvPr id="4" name="Image 0" descr="measured_dS_vs_depth.png">    </p:cNvPr>
+          <p:cNvPicPr>
+            <a:picLocks noChangeAspect="1"/>
+          </p:cNvPicPr>
+          <p:nvPr/>
+        </p:nvPicPr>
+        <p:blipFill>
+          <a:blip r:embed="rId1"/>
+          <a:stretch>
+            <a:fillRect/>
+          </a:stretch>
+        </p:blipFill>
+        <p:spPr>
+          <a:xfrm>
+            <a:off x="411480" y="1783080"/>
+            <a:ext cx="7315200" cy="4297680"/>
+          </a:xfrm>
+          <a:prstGeom prst="rect">
+            <a:avLst/>
+          </a:prstGeom>
+        </p:spPr>
+      </p:pic>
+      <p:sp>
+        <p:nvSpPr>
+          <p:cNvPr id="5" name="Shape 2"/>
+          <p:cNvSpPr/>
+          <p:nvPr/>
+        </p:nvSpPr>
+        <p:spPr>
+          <a:xfrm>
+            <a:off x="7955280" y="1645920"/>
+            <a:ext cx="3703320" cy="4434840"/>
           </a:xfrm>
           <a:prstGeom prst="roundRect">
             <a:avLst>
-              <a:gd name="adj" fmla="val 8036"/>
+              <a:gd name="adj" fmla="val 2222"/>
             </a:avLst>
           </a:prstGeom>
           <a:solidFill>
@@ -4353,128 +4906,73 @@
       </p:sp>
       <p:sp>
         <p:nvSpPr>
-          <p:cNvPr id="5" name="Shape 3"/>
-          <p:cNvSpPr/>
-          <p:nvPr/>
-        </p:nvSpPr>
-        <p:spPr>
-          <a:xfrm>
-            <a:off x="777240" y="1856232"/>
-            <a:ext cx="512064" cy="512064"/>
-          </a:xfrm>
-          <a:prstGeom prst="ellipse">
-            <a:avLst/>
-          </a:prstGeom>
-          <a:solidFill>
-            <a:srgbClr val="BE0000"/>
-          </a:solidFill>
-          <a:ln/>
-        </p:spPr>
-      </p:sp>
-      <p:sp>
-        <p:nvSpPr>
-          <p:cNvPr id="6" name="Text 4"/>
-          <p:cNvSpPr/>
-          <p:nvPr/>
-        </p:nvSpPr>
-        <p:spPr>
-          <a:xfrm>
-            <a:off x="777240" y="1856232"/>
-            <a:ext cx="512064" cy="512064"/>
-          </a:xfrm>
-          <a:prstGeom prst="rect">
-            <a:avLst/>
-          </a:prstGeom>
-          <a:noFill/>
-          <a:ln/>
-        </p:spPr>
-        <p:txBody>
-          <a:bodyPr wrap="square" lIns="0" tIns="0" rIns="0" bIns="0" rtlCol="0" anchor="ctr"/>
-          <a:lstStyle/>
-          <a:p>
-            <a:pPr algn="ctr" indent="0" marL="0">
-              <a:buNone/>
-            </a:pPr>
-            <a:r>
-              <a:rPr lang="en-US" sz="2000" b="1" dirty="0">
-                <a:solidFill>
-                  <a:srgbClr val="FFFFFF"/>
+          <p:cNvPr id="6" name="Text 3"/>
+          <p:cNvSpPr/>
+          <p:nvPr/>
+        </p:nvSpPr>
+        <p:spPr>
+          <a:xfrm>
+            <a:off x="8183880" y="1828800"/>
+            <a:ext cx="3291840" cy="365760"/>
+          </a:xfrm>
+          <a:prstGeom prst="rect">
+            <a:avLst/>
+          </a:prstGeom>
+          <a:noFill/>
+          <a:ln/>
+        </p:spPr>
+        <p:txBody>
+          <a:bodyPr wrap="square" lIns="0" tIns="0" rIns="0" bIns="0" rtlCol="0" anchor="ctr"/>
+          <a:lstStyle/>
+          <a:p>
+            <a:pPr indent="0" marL="0">
+              <a:buNone/>
+            </a:pPr>
+            <a:r>
+              <a:rPr lang="en-US" sz="1600" b="1" dirty="0">
+                <a:solidFill>
+                  <a:srgbClr val="BE0000"/>
                 </a:solidFill>
                 <a:latin typeface="Cambria" pitchFamily="34" charset="0"/>
                 <a:ea typeface="Cambria" pitchFamily="34" charset="-122"/>
                 <a:cs typeface="Cambria" pitchFamily="34" charset="-120"/>
               </a:rPr>
-              <a:t>1</a:t>
-            </a:r>
-            <a:endParaRPr lang="en-US" sz="2000" dirty="0"/>
-          </a:p>
-        </p:txBody>
-      </p:sp>
-      <p:sp>
-        <p:nvSpPr>
-          <p:cNvPr id="7" name="Text 5"/>
-          <p:cNvSpPr/>
-          <p:nvPr/>
-        </p:nvSpPr>
-        <p:spPr>
-          <a:xfrm>
-            <a:off x="1508760" y="1746504"/>
-            <a:ext cx="2011680" cy="731520"/>
-          </a:xfrm>
-          <a:prstGeom prst="rect">
-            <a:avLst/>
-          </a:prstGeom>
-          <a:noFill/>
-          <a:ln/>
-        </p:spPr>
-        <p:txBody>
-          <a:bodyPr wrap="square" lIns="0" tIns="0" rIns="0" bIns="0" rtlCol="0" anchor="ctr"/>
-          <a:lstStyle/>
-          <a:p>
-            <a:pPr indent="0" marL="0">
-              <a:buNone/>
-            </a:pPr>
-            <a:r>
-              <a:rPr lang="en-US" sz="1700" b="1" dirty="0">
-                <a:solidFill>
-                  <a:srgbClr val="BE0000"/>
-                </a:solidFill>
-                <a:latin typeface="Cambria" pitchFamily="34" charset="0"/>
-                <a:ea typeface="Cambria" pitchFamily="34" charset="-122"/>
-                <a:cs typeface="Cambria" pitchFamily="34" charset="-120"/>
-              </a:rPr>
-              <a:t>Input</a:t>
-            </a:r>
-            <a:endParaRPr lang="en-US" sz="1700" dirty="0"/>
-          </a:p>
-        </p:txBody>
-      </p:sp>
-      <p:sp>
-        <p:nvSpPr>
-          <p:cNvPr id="8" name="Text 6"/>
-          <p:cNvSpPr/>
-          <p:nvPr/>
-        </p:nvSpPr>
-        <p:spPr>
-          <a:xfrm>
-            <a:off x="3611880" y="1655064"/>
-            <a:ext cx="7845552" cy="914400"/>
-          </a:xfrm>
-          <a:prstGeom prst="rect">
-            <a:avLst/>
-          </a:prstGeom>
-          <a:noFill/>
-          <a:ln/>
-        </p:spPr>
-        <p:txBody>
-          <a:bodyPr wrap="square" lIns="0" tIns="0" rIns="0" bIns="0" rtlCol="0" anchor="ctr"/>
-          <a:lstStyle/>
-          <a:p>
-            <a:pPr indent="0" marL="0">
-              <a:buNone/>
-            </a:pPr>
-            <a:r>
-              <a:rPr lang="en-US" sz="1250" dirty="0">
+              <a:t>Same story on the bench</a:t>
+            </a:r>
+            <a:endParaRPr lang="en-US" sz="1600" dirty="0"/>
+          </a:p>
+        </p:txBody>
+      </p:sp>
+      <p:sp>
+        <p:nvSpPr>
+          <p:cNvPr id="7" name="Text 4"/>
+          <p:cNvSpPr/>
+          <p:nvPr/>
+        </p:nvSpPr>
+        <p:spPr>
+          <a:xfrm>
+            <a:off x="8183880" y="2331720"/>
+            <a:ext cx="3291840" cy="3657600"/>
+          </a:xfrm>
+          <a:prstGeom prst="rect">
+            <a:avLst/>
+          </a:prstGeom>
+          <a:noFill/>
+          <a:ln/>
+        </p:spPr>
+        <p:txBody>
+          <a:bodyPr wrap="square" lIns="0" tIns="0" rIns="0" bIns="0" rtlCol="0" anchor="t"/>
+          <a:lstStyle/>
+          <a:p>
+            <a:pPr marL="342900" indent="-342900">
+              <a:spcAft>
+                <a:spcPts val="800"/>
+              </a:spcAft>
+              <a:buSzPct val="100000"/>
+              <a:buChar char="•"/>
+            </a:pPr>
+            <a:r>
+              <a:rPr lang="en-US" sz="1200" dirty="0">
                 <a:solidFill>
                   <a:srgbClr val="2A1618"/>
                 </a:solidFill>
@@ -4482,170 +4980,20 @@
                 <a:ea typeface="Calibri" pitchFamily="34" charset="-122"/>
                 <a:cs typeface="Calibri" pitchFamily="34" charset="-120"/>
               </a:rPr>
-              <a:t>dS as a 32 x 256 image (16 S-params x [mag, phase], 256 frequencies). Per-sample z-score normalization.</a:t>
-            </a:r>
-            <a:endParaRPr lang="en-US" sz="1250" dirty="0"/>
-          </a:p>
-        </p:txBody>
-      </p:sp>
-      <p:sp>
-        <p:nvSpPr>
-          <p:cNvPr id="9" name="Shape 7"/>
-          <p:cNvSpPr/>
-          <p:nvPr/>
-        </p:nvSpPr>
-        <p:spPr>
-          <a:xfrm>
-            <a:off x="548640" y="2770632"/>
-            <a:ext cx="11091672" cy="1024128"/>
-          </a:xfrm>
-          <a:prstGeom prst="roundRect">
-            <a:avLst>
-              <a:gd name="adj" fmla="val 8036"/>
-            </a:avLst>
-          </a:prstGeom>
-          <a:solidFill>
-            <a:srgbClr val="FBF4F2"/>
-          </a:solidFill>
-          <a:ln w="12700">
-            <a:solidFill>
-              <a:srgbClr val="E7D6D1"/>
-            </a:solidFill>
-            <a:prstDash val="solid"/>
-          </a:ln>
-          <a:effectLst>
-            <a:outerShdw sx="100000" sy="100000" kx="0" ky="0" algn="bl" rotWithShape="0" blurRad="88900" dist="38100" dir="5400000">
-              <a:srgbClr val="7A5C5E">
-                <a:alpha val="18000"/>
-              </a:srgbClr>
-            </a:outerShdw>
-          </a:effectLst>
-        </p:spPr>
-      </p:sp>
-      <p:sp>
-        <p:nvSpPr>
-          <p:cNvPr id="10" name="Shape 8"/>
-          <p:cNvSpPr/>
-          <p:nvPr/>
-        </p:nvSpPr>
-        <p:spPr>
-          <a:xfrm>
-            <a:off x="777240" y="3026664"/>
-            <a:ext cx="512064" cy="512064"/>
-          </a:xfrm>
-          <a:prstGeom prst="ellipse">
-            <a:avLst/>
-          </a:prstGeom>
-          <a:solidFill>
-            <a:srgbClr val="BE0000"/>
-          </a:solidFill>
-          <a:ln/>
-        </p:spPr>
-      </p:sp>
-      <p:sp>
-        <p:nvSpPr>
-          <p:cNvPr id="11" name="Text 9"/>
-          <p:cNvSpPr/>
-          <p:nvPr/>
-        </p:nvSpPr>
-        <p:spPr>
-          <a:xfrm>
-            <a:off x="777240" y="3026664"/>
-            <a:ext cx="512064" cy="512064"/>
-          </a:xfrm>
-          <a:prstGeom prst="rect">
-            <a:avLst/>
-          </a:prstGeom>
-          <a:noFill/>
-          <a:ln/>
-        </p:spPr>
-        <p:txBody>
-          <a:bodyPr wrap="square" lIns="0" tIns="0" rIns="0" bIns="0" rtlCol="0" anchor="ctr"/>
-          <a:lstStyle/>
-          <a:p>
-            <a:pPr algn="ctr" indent="0" marL="0">
-              <a:buNone/>
-            </a:pPr>
-            <a:r>
-              <a:rPr lang="en-US" sz="2000" b="1" dirty="0">
-                <a:solidFill>
-                  <a:srgbClr val="FFFFFF"/>
-                </a:solidFill>
-                <a:latin typeface="Cambria" pitchFamily="34" charset="0"/>
-                <a:ea typeface="Cambria" pitchFamily="34" charset="-122"/>
-                <a:cs typeface="Cambria" pitchFamily="34" charset="-120"/>
-              </a:rPr>
-              <a:t>2</a:t>
-            </a:r>
-            <a:endParaRPr lang="en-US" sz="2000" dirty="0"/>
-          </a:p>
-        </p:txBody>
-      </p:sp>
-      <p:sp>
-        <p:nvSpPr>
-          <p:cNvPr id="12" name="Text 10"/>
-          <p:cNvSpPr/>
-          <p:nvPr/>
-        </p:nvSpPr>
-        <p:spPr>
-          <a:xfrm>
-            <a:off x="1508760" y="2916936"/>
-            <a:ext cx="2011680" cy="731520"/>
-          </a:xfrm>
-          <a:prstGeom prst="rect">
-            <a:avLst/>
-          </a:prstGeom>
-          <a:noFill/>
-          <a:ln/>
-        </p:spPr>
-        <p:txBody>
-          <a:bodyPr wrap="square" lIns="0" tIns="0" rIns="0" bIns="0" rtlCol="0" anchor="ctr"/>
-          <a:lstStyle/>
-          <a:p>
-            <a:pPr indent="0" marL="0">
-              <a:buNone/>
-            </a:pPr>
-            <a:r>
-              <a:rPr lang="en-US" sz="1700" b="1" dirty="0">
-                <a:solidFill>
-                  <a:srgbClr val="BE0000"/>
-                </a:solidFill>
-                <a:latin typeface="Cambria" pitchFamily="34" charset="0"/>
-                <a:ea typeface="Cambria" pitchFamily="34" charset="-122"/>
-                <a:cs typeface="Cambria" pitchFamily="34" charset="-120"/>
-              </a:rPr>
-              <a:t>Trunk</a:t>
-            </a:r>
-            <a:endParaRPr lang="en-US" sz="1700" dirty="0"/>
-          </a:p>
-        </p:txBody>
-      </p:sp>
-      <p:sp>
-        <p:nvSpPr>
-          <p:cNvPr id="13" name="Text 11"/>
-          <p:cNvSpPr/>
-          <p:nvPr/>
-        </p:nvSpPr>
-        <p:spPr>
-          <a:xfrm>
-            <a:off x="3611880" y="2825496"/>
-            <a:ext cx="7845552" cy="914400"/>
-          </a:xfrm>
-          <a:prstGeom prst="rect">
-            <a:avLst/>
-          </a:prstGeom>
-          <a:noFill/>
-          <a:ln/>
-        </p:spPr>
-        <p:txBody>
-          <a:bodyPr wrap="square" lIns="0" tIns="0" rIns="0" bIns="0" rtlCol="0" anchor="ctr"/>
-          <a:lstStyle/>
-          <a:p>
-            <a:pPr indent="0" marL="0">
-              <a:buNone/>
-            </a:pPr>
-            <a:r>
-              <a:rPr lang="en-US" sz="1250" dirty="0">
+              <a:t>4 measured tumor heights (July10), a full 51-position grid at each.</a:t>
+            </a:r>
+            <a:endParaRPr lang="en-US" sz="1200" dirty="0"/>
+          </a:p>
+          <a:p>
+            <a:pPr marL="342900" indent="-342900">
+              <a:spcAft>
+                <a:spcPts val="800"/>
+              </a:spcAft>
+              <a:buSzPct val="100000"/>
+              <a:buChar char="•"/>
+            </a:pPr>
+            <a:r>
+              <a:rPr lang="en-US" sz="1200" dirty="0">
                 <a:solidFill>
                   <a:srgbClr val="2A1618"/>
                 </a:solidFill>
@@ -4653,170 +5001,20 @@
                 <a:ea typeface="Calibri" pitchFamily="34" charset="-122"/>
                 <a:cs typeface="Calibri" pitchFamily="34" charset="-120"/>
               </a:rPr>
-              <a:t>2 conv blocks (32 filters each) plus pooling and dropout, identical to the measured (x,y) CNN.</a:t>
-            </a:r>
-            <a:endParaRPr lang="en-US" sz="1250" dirty="0"/>
-          </a:p>
-        </p:txBody>
-      </p:sp>
-      <p:sp>
-        <p:nvSpPr>
-          <p:cNvPr id="14" name="Shape 12"/>
-          <p:cNvSpPr/>
-          <p:nvPr/>
-        </p:nvSpPr>
-        <p:spPr>
-          <a:xfrm>
-            <a:off x="548640" y="3941064"/>
-            <a:ext cx="11091672" cy="1024128"/>
-          </a:xfrm>
-          <a:prstGeom prst="roundRect">
-            <a:avLst>
-              <a:gd name="adj" fmla="val 8036"/>
-            </a:avLst>
-          </a:prstGeom>
-          <a:solidFill>
-            <a:srgbClr val="FBF4F2"/>
-          </a:solidFill>
-          <a:ln w="12700">
-            <a:solidFill>
-              <a:srgbClr val="E7D6D1"/>
-            </a:solidFill>
-            <a:prstDash val="solid"/>
-          </a:ln>
-          <a:effectLst>
-            <a:outerShdw sx="100000" sy="100000" kx="0" ky="0" algn="bl" rotWithShape="0" blurRad="88900" dist="38100" dir="5400000">
-              <a:srgbClr val="7A5C5E">
-                <a:alpha val="18000"/>
-              </a:srgbClr>
-            </a:outerShdw>
-          </a:effectLst>
-        </p:spPr>
-      </p:sp>
-      <p:sp>
-        <p:nvSpPr>
-          <p:cNvPr id="15" name="Shape 13"/>
-          <p:cNvSpPr/>
-          <p:nvPr/>
-        </p:nvSpPr>
-        <p:spPr>
-          <a:xfrm>
-            <a:off x="777240" y="4197096"/>
-            <a:ext cx="512064" cy="512064"/>
-          </a:xfrm>
-          <a:prstGeom prst="ellipse">
-            <a:avLst/>
-          </a:prstGeom>
-          <a:solidFill>
-            <a:srgbClr val="BE0000"/>
-          </a:solidFill>
-          <a:ln/>
-        </p:spPr>
-      </p:sp>
-      <p:sp>
-        <p:nvSpPr>
-          <p:cNvPr id="16" name="Text 14"/>
-          <p:cNvSpPr/>
-          <p:nvPr/>
-        </p:nvSpPr>
-        <p:spPr>
-          <a:xfrm>
-            <a:off x="777240" y="4197096"/>
-            <a:ext cx="512064" cy="512064"/>
-          </a:xfrm>
-          <a:prstGeom prst="rect">
-            <a:avLst/>
-          </a:prstGeom>
-          <a:noFill/>
-          <a:ln/>
-        </p:spPr>
-        <p:txBody>
-          <a:bodyPr wrap="square" lIns="0" tIns="0" rIns="0" bIns="0" rtlCol="0" anchor="ctr"/>
-          <a:lstStyle/>
-          <a:p>
-            <a:pPr algn="ctr" indent="0" marL="0">
-              <a:buNone/>
-            </a:pPr>
-            <a:r>
-              <a:rPr lang="en-US" sz="2000" b="1" dirty="0">
-                <a:solidFill>
-                  <a:srgbClr val="FFFFFF"/>
-                </a:solidFill>
-                <a:latin typeface="Cambria" pitchFamily="34" charset="0"/>
-                <a:ea typeface="Cambria" pitchFamily="34" charset="-122"/>
-                <a:cs typeface="Cambria" pitchFamily="34" charset="-120"/>
-              </a:rPr>
-              <a:t>3</a:t>
-            </a:r>
-            <a:endParaRPr lang="en-US" sz="2000" dirty="0"/>
-          </a:p>
-        </p:txBody>
-      </p:sp>
-      <p:sp>
-        <p:nvSpPr>
-          <p:cNvPr id="17" name="Text 15"/>
-          <p:cNvSpPr/>
-          <p:nvPr/>
-        </p:nvSpPr>
-        <p:spPr>
-          <a:xfrm>
-            <a:off x="1508760" y="4087368"/>
-            <a:ext cx="2011680" cy="731520"/>
-          </a:xfrm>
-          <a:prstGeom prst="rect">
-            <a:avLst/>
-          </a:prstGeom>
-          <a:noFill/>
-          <a:ln/>
-        </p:spPr>
-        <p:txBody>
-          <a:bodyPr wrap="square" lIns="0" tIns="0" rIns="0" bIns="0" rtlCol="0" anchor="ctr"/>
-          <a:lstStyle/>
-          <a:p>
-            <a:pPr indent="0" marL="0">
-              <a:buNone/>
-            </a:pPr>
-            <a:r>
-              <a:rPr lang="en-US" sz="1700" b="1" dirty="0">
-                <a:solidFill>
-                  <a:srgbClr val="BE0000"/>
-                </a:solidFill>
-                <a:latin typeface="Cambria" pitchFamily="34" charset="0"/>
-                <a:ea typeface="Cambria" pitchFamily="34" charset="-122"/>
-                <a:cs typeface="Cambria" pitchFamily="34" charset="-120"/>
-              </a:rPr>
-              <a:t>Head</a:t>
-            </a:r>
-            <a:endParaRPr lang="en-US" sz="1700" dirty="0"/>
-          </a:p>
-        </p:txBody>
-      </p:sp>
-      <p:sp>
-        <p:nvSpPr>
-          <p:cNvPr id="18" name="Text 16"/>
-          <p:cNvSpPr/>
-          <p:nvPr/>
-        </p:nvSpPr>
-        <p:spPr>
-          <a:xfrm>
-            <a:off x="3611880" y="3995928"/>
-            <a:ext cx="7845552" cy="914400"/>
-          </a:xfrm>
-          <a:prstGeom prst="rect">
-            <a:avLst/>
-          </a:prstGeom>
-          <a:noFill/>
-          <a:ln/>
-        </p:spPr>
-        <p:txBody>
-          <a:bodyPr wrap="square" lIns="0" tIns="0" rIns="0" bIns="0" rtlCol="0" anchor="ctr"/>
-          <a:lstStyle/>
-          <a:p>
-            <a:pPr indent="0" marL="0">
-              <a:buNone/>
-            </a:pPr>
-            <a:r>
-              <a:rPr lang="en-US" sz="1250" dirty="0">
+              <a:t>Mean |dS| peaks at +15 mm, right at the radiating patch, exactly like the sim.</a:t>
+            </a:r>
+            <a:endParaRPr lang="en-US" sz="1200" dirty="0"/>
+          </a:p>
+          <a:p>
+            <a:pPr marL="342900" indent="-342900">
+              <a:spcAft>
+                <a:spcPts val="800"/>
+              </a:spcAft>
+              <a:buSzPct val="100000"/>
+              <a:buChar char="•"/>
+            </a:pPr>
+            <a:r>
+              <a:rPr lang="en-US" sz="1200" dirty="0">
                 <a:solidFill>
                   <a:srgbClr val="2A1618"/>
                 </a:solidFill>
@@ -4824,170 +5022,20 @@
                 <a:ea typeface="Calibri" pitchFamily="34" charset="-122"/>
                 <a:cs typeface="Calibri" pitchFamily="34" charset="-120"/>
               </a:rPr>
-              <a:t>fc(3) plus regression to (x, y, z) in mm. Trained with an L2 coordinate loss, 60 epochs.</a:t>
-            </a:r>
-            <a:endParaRPr lang="en-US" sz="1250" dirty="0"/>
-          </a:p>
-        </p:txBody>
-      </p:sp>
-      <p:sp>
-        <p:nvSpPr>
-          <p:cNvPr id="19" name="Shape 17"/>
-          <p:cNvSpPr/>
-          <p:nvPr/>
-        </p:nvSpPr>
-        <p:spPr>
-          <a:xfrm>
-            <a:off x="548640" y="5111496"/>
-            <a:ext cx="11091672" cy="1024128"/>
-          </a:xfrm>
-          <a:prstGeom prst="roundRect">
-            <a:avLst>
-              <a:gd name="adj" fmla="val 8036"/>
-            </a:avLst>
-          </a:prstGeom>
-          <a:solidFill>
-            <a:srgbClr val="FBF4F2"/>
-          </a:solidFill>
-          <a:ln w="12700">
-            <a:solidFill>
-              <a:srgbClr val="E7D6D1"/>
-            </a:solidFill>
-            <a:prstDash val="solid"/>
-          </a:ln>
-          <a:effectLst>
-            <a:outerShdw sx="100000" sy="100000" kx="0" ky="0" algn="bl" rotWithShape="0" blurRad="88900" dist="38100" dir="5400000">
-              <a:srgbClr val="7A5C5E">
-                <a:alpha val="18000"/>
-              </a:srgbClr>
-            </a:outerShdw>
-          </a:effectLst>
-        </p:spPr>
-      </p:sp>
-      <p:sp>
-        <p:nvSpPr>
-          <p:cNvPr id="20" name="Shape 18"/>
-          <p:cNvSpPr/>
-          <p:nvPr/>
-        </p:nvSpPr>
-        <p:spPr>
-          <a:xfrm>
-            <a:off x="777240" y="5367528"/>
-            <a:ext cx="512064" cy="512064"/>
-          </a:xfrm>
-          <a:prstGeom prst="ellipse">
-            <a:avLst/>
-          </a:prstGeom>
-          <a:solidFill>
-            <a:srgbClr val="BE0000"/>
-          </a:solidFill>
-          <a:ln/>
-        </p:spPr>
-      </p:sp>
-      <p:sp>
-        <p:nvSpPr>
-          <p:cNvPr id="21" name="Text 19"/>
-          <p:cNvSpPr/>
-          <p:nvPr/>
-        </p:nvSpPr>
-        <p:spPr>
-          <a:xfrm>
-            <a:off x="777240" y="5367528"/>
-            <a:ext cx="512064" cy="512064"/>
-          </a:xfrm>
-          <a:prstGeom prst="rect">
-            <a:avLst/>
-          </a:prstGeom>
-          <a:noFill/>
-          <a:ln/>
-        </p:spPr>
-        <p:txBody>
-          <a:bodyPr wrap="square" lIns="0" tIns="0" rIns="0" bIns="0" rtlCol="0" anchor="ctr"/>
-          <a:lstStyle/>
-          <a:p>
-            <a:pPr algn="ctr" indent="0" marL="0">
-              <a:buNone/>
-            </a:pPr>
-            <a:r>
-              <a:rPr lang="en-US" sz="2000" b="1" dirty="0">
-                <a:solidFill>
-                  <a:srgbClr val="FFFFFF"/>
-                </a:solidFill>
-                <a:latin typeface="Cambria" pitchFamily="34" charset="0"/>
-                <a:ea typeface="Cambria" pitchFamily="34" charset="-122"/>
-                <a:cs typeface="Cambria" pitchFamily="34" charset="-120"/>
-              </a:rPr>
-              <a:t>4</a:t>
-            </a:r>
-            <a:endParaRPr lang="en-US" sz="2000" dirty="0"/>
-          </a:p>
-        </p:txBody>
-      </p:sp>
-      <p:sp>
-        <p:nvSpPr>
-          <p:cNvPr id="22" name="Text 20"/>
-          <p:cNvSpPr/>
-          <p:nvPr/>
-        </p:nvSpPr>
-        <p:spPr>
-          <a:xfrm>
-            <a:off x="1508760" y="5257800"/>
-            <a:ext cx="2011680" cy="731520"/>
-          </a:xfrm>
-          <a:prstGeom prst="rect">
-            <a:avLst/>
-          </a:prstGeom>
-          <a:noFill/>
-          <a:ln/>
-        </p:spPr>
-        <p:txBody>
-          <a:bodyPr wrap="square" lIns="0" tIns="0" rIns="0" bIns="0" rtlCol="0" anchor="ctr"/>
-          <a:lstStyle/>
-          <a:p>
-            <a:pPr indent="0" marL="0">
-              <a:buNone/>
-            </a:pPr>
-            <a:r>
-              <a:rPr lang="en-US" sz="1700" b="1" dirty="0">
-                <a:solidFill>
-                  <a:srgbClr val="BE0000"/>
-                </a:solidFill>
-                <a:latin typeface="Cambria" pitchFamily="34" charset="0"/>
-                <a:ea typeface="Cambria" pitchFamily="34" charset="-122"/>
-                <a:cs typeface="Cambria" pitchFamily="34" charset="-120"/>
-              </a:rPr>
-              <a:t>Evaluation</a:t>
-            </a:r>
-            <a:endParaRPr lang="en-US" sz="1700" dirty="0"/>
-          </a:p>
-        </p:txBody>
-      </p:sp>
-      <p:sp>
-        <p:nvSpPr>
-          <p:cNvPr id="23" name="Text 21"/>
-          <p:cNvSpPr/>
-          <p:nvPr/>
-        </p:nvSpPr>
-        <p:spPr>
-          <a:xfrm>
-            <a:off x="3611880" y="5166360"/>
-            <a:ext cx="7845552" cy="914400"/>
-          </a:xfrm>
-          <a:prstGeom prst="rect">
-            <a:avLst/>
-          </a:prstGeom>
-          <a:noFill/>
-          <a:ln/>
-        </p:spPr>
-        <p:txBody>
-          <a:bodyPr wrap="square" lIns="0" tIns="0" rIns="0" bIns="0" rtlCol="0" anchor="ctr"/>
-          <a:lstStyle/>
-          <a:p>
-            <a:pPr indent="0" marL="0">
-              <a:buNone/>
-            </a:pPr>
-            <a:r>
-              <a:rPr lang="en-US" sz="1250" dirty="0">
+              <a:t>Falls off both ways; the bench and the simulation agree on where the signal lives.</a:t>
+            </a:r>
+            <a:endParaRPr lang="en-US" sz="1200" dirty="0"/>
+          </a:p>
+          <a:p>
+            <a:pPr marL="342900" indent="-342900">
+              <a:spcAft>
+                <a:spcPts val="800"/>
+              </a:spcAft>
+              <a:buSzPct val="100000"/>
+              <a:buChar char="•"/>
+            </a:pPr>
+            <a:r>
+              <a:rPr lang="en-US" sz="1200" dirty="0">
                 <a:solidFill>
                   <a:srgbClr val="2A1618"/>
                 </a:solidFill>
@@ -4995,9 +5043,9 @@
                 <a:ea typeface="Calibri" pitchFamily="34" charset="-122"/>
                 <a:cs typeface="Calibri" pitchFamily="34" charset="-120"/>
               </a:rPr>
-              <a:t>8-fold hold-out by POSITION (every position predicted once, out-of-fold). Lateral = sqrt(dx^2+dy^2); depth = |dz|, reported separately so one axis cannot hide the other.</a:t>
-            </a:r>
-            <a:endParaRPr lang="en-US" sz="1250" dirty="0"/>
+              <a:t>Depths are port-relative; the +25 mm session was mislabeled '2.5 cm below' in the README.</a:t>
+            </a:r>
+            <a:endParaRPr lang="en-US" sz="1200" dirty="0"/>
           </a:p>
         </p:txBody>
       </p:sp>
@@ -5066,7 +5114,7 @@
                 <a:ea typeface="Cambria" pitchFamily="34" charset="-122"/>
                 <a:cs typeface="Cambria" pitchFamily="34" charset="-120"/>
               </a:rPr>
-              <a:t>How much data does the CNN need?</a:t>
+              <a:t>The 3D localization network</a:t>
             </a:r>
             <a:endParaRPr lang="en-US" sz="2900" dirty="0"/>
           </a:p>
@@ -5105,50 +5153,26 @@
                 <a:ea typeface="Calibri" pitchFamily="34" charset="-122"/>
                 <a:cs typeface="Calibri" pitchFamily="34" charset="-120"/>
               </a:rPr>
-              <a:t>Train on more depth planes (more distinct positions) and watch the error fall</a:t>
+              <a:t>Same architecture as the measured CNN, with one extra output for depth</a:t>
             </a:r>
             <a:endParaRPr lang="en-US" sz="1400" dirty="0"/>
           </a:p>
         </p:txBody>
       </p:sp>
-      <p:pic>
-        <p:nvPicPr>
-          <p:cNvPr id="4" name="Image 0" descr="sim_depth_learning_curve.png">    </p:cNvPr>
-          <p:cNvPicPr>
-            <a:picLocks noChangeAspect="1"/>
-          </p:cNvPicPr>
-          <p:nvPr/>
-        </p:nvPicPr>
-        <p:blipFill>
-          <a:blip r:embed="rId1"/>
-          <a:stretch>
-            <a:fillRect/>
-          </a:stretch>
-        </p:blipFill>
-        <p:spPr>
-          <a:xfrm>
-            <a:off x="457200" y="1600200"/>
-            <a:ext cx="7223760" cy="4498848"/>
-          </a:xfrm>
-          <a:prstGeom prst="rect">
-            <a:avLst/>
-          </a:prstGeom>
-        </p:spPr>
-      </p:pic>
-      <p:sp>
-        <p:nvSpPr>
-          <p:cNvPr id="5" name="Shape 2"/>
-          <p:cNvSpPr/>
-          <p:nvPr/>
-        </p:nvSpPr>
-        <p:spPr>
-          <a:xfrm>
-            <a:off x="7863840" y="1600200"/>
-            <a:ext cx="3794760" cy="4498848"/>
+      <p:sp>
+        <p:nvSpPr>
+          <p:cNvPr id="4" name="Shape 2"/>
+          <p:cNvSpPr/>
+          <p:nvPr/>
+        </p:nvSpPr>
+        <p:spPr>
+          <a:xfrm>
+            <a:off x="548640" y="1600200"/>
+            <a:ext cx="11091672" cy="1024128"/>
           </a:xfrm>
           <a:prstGeom prst="roundRect">
             <a:avLst>
-              <a:gd name="adj" fmla="val 2169"/>
+              <a:gd name="adj" fmla="val 8036"/>
             </a:avLst>
           </a:prstGeom>
           <a:solidFill>
@@ -5171,73 +5195,128 @@
       </p:sp>
       <p:sp>
         <p:nvSpPr>
-          <p:cNvPr id="6" name="Text 3"/>
-          <p:cNvSpPr/>
-          <p:nvPr/>
-        </p:nvSpPr>
-        <p:spPr>
-          <a:xfrm>
-            <a:off x="8092440" y="1783080"/>
-            <a:ext cx="3383280" cy="365760"/>
-          </a:xfrm>
-          <a:prstGeom prst="rect">
-            <a:avLst/>
-          </a:prstGeom>
-          <a:noFill/>
-          <a:ln/>
-        </p:spPr>
-        <p:txBody>
-          <a:bodyPr wrap="square" lIns="0" tIns="0" rIns="0" bIns="0" rtlCol="0" anchor="ctr"/>
-          <a:lstStyle/>
-          <a:p>
-            <a:pPr indent="0" marL="0">
-              <a:buNone/>
-            </a:pPr>
-            <a:r>
-              <a:rPr lang="en-US" sz="1600" b="1" dirty="0">
-                <a:solidFill>
-                  <a:srgbClr val="BE0000"/>
+          <p:cNvPr id="5" name="Shape 3"/>
+          <p:cNvSpPr/>
+          <p:nvPr/>
+        </p:nvSpPr>
+        <p:spPr>
+          <a:xfrm>
+            <a:off x="777240" y="1856232"/>
+            <a:ext cx="512064" cy="512064"/>
+          </a:xfrm>
+          <a:prstGeom prst="ellipse">
+            <a:avLst/>
+          </a:prstGeom>
+          <a:solidFill>
+            <a:srgbClr val="BE0000"/>
+          </a:solidFill>
+          <a:ln/>
+        </p:spPr>
+      </p:sp>
+      <p:sp>
+        <p:nvSpPr>
+          <p:cNvPr id="6" name="Text 4"/>
+          <p:cNvSpPr/>
+          <p:nvPr/>
+        </p:nvSpPr>
+        <p:spPr>
+          <a:xfrm>
+            <a:off x="777240" y="1856232"/>
+            <a:ext cx="512064" cy="512064"/>
+          </a:xfrm>
+          <a:prstGeom prst="rect">
+            <a:avLst/>
+          </a:prstGeom>
+          <a:noFill/>
+          <a:ln/>
+        </p:spPr>
+        <p:txBody>
+          <a:bodyPr wrap="square" lIns="0" tIns="0" rIns="0" bIns="0" rtlCol="0" anchor="ctr"/>
+          <a:lstStyle/>
+          <a:p>
+            <a:pPr algn="ctr" indent="0" marL="0">
+              <a:buNone/>
+            </a:pPr>
+            <a:r>
+              <a:rPr lang="en-US" sz="2000" b="1" dirty="0">
+                <a:solidFill>
+                  <a:srgbClr val="FFFFFF"/>
                 </a:solidFill>
                 <a:latin typeface="Cambria" pitchFamily="34" charset="0"/>
                 <a:ea typeface="Cambria" pitchFamily="34" charset="-122"/>
                 <a:cs typeface="Cambria" pitchFamily="34" charset="-120"/>
               </a:rPr>
-              <a:t>The threshold</a:t>
-            </a:r>
-            <a:endParaRPr lang="en-US" sz="1600" dirty="0"/>
-          </a:p>
-        </p:txBody>
-      </p:sp>
-      <p:sp>
-        <p:nvSpPr>
-          <p:cNvPr id="7" name="Text 4"/>
-          <p:cNvSpPr/>
-          <p:nvPr/>
-        </p:nvSpPr>
-        <p:spPr>
-          <a:xfrm>
-            <a:off x="8092440" y="2286000"/>
-            <a:ext cx="3383280" cy="3657600"/>
-          </a:xfrm>
-          <a:prstGeom prst="rect">
-            <a:avLst/>
-          </a:prstGeom>
-          <a:noFill/>
-          <a:ln/>
-        </p:spPr>
-        <p:txBody>
-          <a:bodyPr wrap="square" lIns="0" tIns="0" rIns="0" bIns="0" rtlCol="0" anchor="t"/>
-          <a:lstStyle/>
-          <a:p>
-            <a:pPr marL="342900" indent="-342900">
-              <a:spcAft>
-                <a:spcPts val="800"/>
-              </a:spcAft>
-              <a:buSzPct val="100000"/>
-              <a:buChar char="•"/>
-            </a:pPr>
-            <a:r>
-              <a:rPr lang="en-US" sz="1200" dirty="0">
+              <a:t>1</a:t>
+            </a:r>
+            <a:endParaRPr lang="en-US" sz="2000" dirty="0"/>
+          </a:p>
+        </p:txBody>
+      </p:sp>
+      <p:sp>
+        <p:nvSpPr>
+          <p:cNvPr id="7" name="Text 5"/>
+          <p:cNvSpPr/>
+          <p:nvPr/>
+        </p:nvSpPr>
+        <p:spPr>
+          <a:xfrm>
+            <a:off x="1508760" y="1746504"/>
+            <a:ext cx="2011680" cy="731520"/>
+          </a:xfrm>
+          <a:prstGeom prst="rect">
+            <a:avLst/>
+          </a:prstGeom>
+          <a:noFill/>
+          <a:ln/>
+        </p:spPr>
+        <p:txBody>
+          <a:bodyPr wrap="square" lIns="0" tIns="0" rIns="0" bIns="0" rtlCol="0" anchor="ctr"/>
+          <a:lstStyle/>
+          <a:p>
+            <a:pPr indent="0" marL="0">
+              <a:buNone/>
+            </a:pPr>
+            <a:r>
+              <a:rPr lang="en-US" sz="1700" b="1" dirty="0">
+                <a:solidFill>
+                  <a:srgbClr val="BE0000"/>
+                </a:solidFill>
+                <a:latin typeface="Cambria" pitchFamily="34" charset="0"/>
+                <a:ea typeface="Cambria" pitchFamily="34" charset="-122"/>
+                <a:cs typeface="Cambria" pitchFamily="34" charset="-120"/>
+              </a:rPr>
+              <a:t>Input</a:t>
+            </a:r>
+            <a:endParaRPr lang="en-US" sz="1700" dirty="0"/>
+          </a:p>
+        </p:txBody>
+      </p:sp>
+      <p:sp>
+        <p:nvSpPr>
+          <p:cNvPr id="8" name="Text 6"/>
+          <p:cNvSpPr/>
+          <p:nvPr/>
+        </p:nvSpPr>
+        <p:spPr>
+          <a:xfrm>
+            <a:off x="3611880" y="1655064"/>
+            <a:ext cx="7845552" cy="914400"/>
+          </a:xfrm>
+          <a:prstGeom prst="rect">
+            <a:avLst/>
+          </a:prstGeom>
+          <a:noFill/>
+          <a:ln/>
+        </p:spPr>
+        <p:txBody>
+          <a:bodyPr wrap="square" lIns="0" tIns="0" rIns="0" bIns="0" rtlCol="0" anchor="ctr"/>
+          <a:lstStyle/>
+          <a:p>
+            <a:pPr indent="0" marL="0">
+              <a:buNone/>
+            </a:pPr>
+            <a:r>
+              <a:rPr lang="en-US" sz="1250" dirty="0">
                 <a:solidFill>
                   <a:srgbClr val="2A1618"/>
                 </a:solidFill>
@@ -5245,20 +5324,170 @@
                 <a:ea typeface="Calibri" pitchFamily="34" charset="-122"/>
                 <a:cs typeface="Calibri" pitchFamily="34" charset="-120"/>
               </a:rPr>
-              <a:t>1 depth plane (82 positions): 33 mm, about chance. The conv net cannot train.</a:t>
-            </a:r>
-            <a:endParaRPr lang="en-US" sz="1200" dirty="0"/>
-          </a:p>
-          <a:p>
-            <a:pPr marL="342900" indent="-342900">
-              <a:spcAft>
-                <a:spcPts val="800"/>
-              </a:spcAft>
-              <a:buSzPct val="100000"/>
-              <a:buChar char="•"/>
-            </a:pPr>
-            <a:r>
-              <a:rPr lang="en-US" sz="1200" dirty="0">
+              <a:t>dS as a 32 x 256 image (16 S-params x [mag, phase], 256 frequencies). Per-sample z-score normalization.</a:t>
+            </a:r>
+            <a:endParaRPr lang="en-US" sz="1250" dirty="0"/>
+          </a:p>
+        </p:txBody>
+      </p:sp>
+      <p:sp>
+        <p:nvSpPr>
+          <p:cNvPr id="9" name="Shape 7"/>
+          <p:cNvSpPr/>
+          <p:nvPr/>
+        </p:nvSpPr>
+        <p:spPr>
+          <a:xfrm>
+            <a:off x="548640" y="2770632"/>
+            <a:ext cx="11091672" cy="1024128"/>
+          </a:xfrm>
+          <a:prstGeom prst="roundRect">
+            <a:avLst>
+              <a:gd name="adj" fmla="val 8036"/>
+            </a:avLst>
+          </a:prstGeom>
+          <a:solidFill>
+            <a:srgbClr val="FBF4F2"/>
+          </a:solidFill>
+          <a:ln w="12700">
+            <a:solidFill>
+              <a:srgbClr val="E7D6D1"/>
+            </a:solidFill>
+            <a:prstDash val="solid"/>
+          </a:ln>
+          <a:effectLst>
+            <a:outerShdw sx="100000" sy="100000" kx="0" ky="0" algn="bl" rotWithShape="0" blurRad="88900" dist="38100" dir="5400000">
+              <a:srgbClr val="7A5C5E">
+                <a:alpha val="18000"/>
+              </a:srgbClr>
+            </a:outerShdw>
+          </a:effectLst>
+        </p:spPr>
+      </p:sp>
+      <p:sp>
+        <p:nvSpPr>
+          <p:cNvPr id="10" name="Shape 8"/>
+          <p:cNvSpPr/>
+          <p:nvPr/>
+        </p:nvSpPr>
+        <p:spPr>
+          <a:xfrm>
+            <a:off x="777240" y="3026664"/>
+            <a:ext cx="512064" cy="512064"/>
+          </a:xfrm>
+          <a:prstGeom prst="ellipse">
+            <a:avLst/>
+          </a:prstGeom>
+          <a:solidFill>
+            <a:srgbClr val="BE0000"/>
+          </a:solidFill>
+          <a:ln/>
+        </p:spPr>
+      </p:sp>
+      <p:sp>
+        <p:nvSpPr>
+          <p:cNvPr id="11" name="Text 9"/>
+          <p:cNvSpPr/>
+          <p:nvPr/>
+        </p:nvSpPr>
+        <p:spPr>
+          <a:xfrm>
+            <a:off x="777240" y="3026664"/>
+            <a:ext cx="512064" cy="512064"/>
+          </a:xfrm>
+          <a:prstGeom prst="rect">
+            <a:avLst/>
+          </a:prstGeom>
+          <a:noFill/>
+          <a:ln/>
+        </p:spPr>
+        <p:txBody>
+          <a:bodyPr wrap="square" lIns="0" tIns="0" rIns="0" bIns="0" rtlCol="0" anchor="ctr"/>
+          <a:lstStyle/>
+          <a:p>
+            <a:pPr algn="ctr" indent="0" marL="0">
+              <a:buNone/>
+            </a:pPr>
+            <a:r>
+              <a:rPr lang="en-US" sz="2000" b="1" dirty="0">
+                <a:solidFill>
+                  <a:srgbClr val="FFFFFF"/>
+                </a:solidFill>
+                <a:latin typeface="Cambria" pitchFamily="34" charset="0"/>
+                <a:ea typeface="Cambria" pitchFamily="34" charset="-122"/>
+                <a:cs typeface="Cambria" pitchFamily="34" charset="-120"/>
+              </a:rPr>
+              <a:t>2</a:t>
+            </a:r>
+            <a:endParaRPr lang="en-US" sz="2000" dirty="0"/>
+          </a:p>
+        </p:txBody>
+      </p:sp>
+      <p:sp>
+        <p:nvSpPr>
+          <p:cNvPr id="12" name="Text 10"/>
+          <p:cNvSpPr/>
+          <p:nvPr/>
+        </p:nvSpPr>
+        <p:spPr>
+          <a:xfrm>
+            <a:off x="1508760" y="2916936"/>
+            <a:ext cx="2011680" cy="731520"/>
+          </a:xfrm>
+          <a:prstGeom prst="rect">
+            <a:avLst/>
+          </a:prstGeom>
+          <a:noFill/>
+          <a:ln/>
+        </p:spPr>
+        <p:txBody>
+          <a:bodyPr wrap="square" lIns="0" tIns="0" rIns="0" bIns="0" rtlCol="0" anchor="ctr"/>
+          <a:lstStyle/>
+          <a:p>
+            <a:pPr indent="0" marL="0">
+              <a:buNone/>
+            </a:pPr>
+            <a:r>
+              <a:rPr lang="en-US" sz="1700" b="1" dirty="0">
+                <a:solidFill>
+                  <a:srgbClr val="BE0000"/>
+                </a:solidFill>
+                <a:latin typeface="Cambria" pitchFamily="34" charset="0"/>
+                <a:ea typeface="Cambria" pitchFamily="34" charset="-122"/>
+                <a:cs typeface="Cambria" pitchFamily="34" charset="-120"/>
+              </a:rPr>
+              <a:t>Trunk</a:t>
+            </a:r>
+            <a:endParaRPr lang="en-US" sz="1700" dirty="0"/>
+          </a:p>
+        </p:txBody>
+      </p:sp>
+      <p:sp>
+        <p:nvSpPr>
+          <p:cNvPr id="13" name="Text 11"/>
+          <p:cNvSpPr/>
+          <p:nvPr/>
+        </p:nvSpPr>
+        <p:spPr>
+          <a:xfrm>
+            <a:off x="3611880" y="2825496"/>
+            <a:ext cx="7845552" cy="914400"/>
+          </a:xfrm>
+          <a:prstGeom prst="rect">
+            <a:avLst/>
+          </a:prstGeom>
+          <a:noFill/>
+          <a:ln/>
+        </p:spPr>
+        <p:txBody>
+          <a:bodyPr wrap="square" lIns="0" tIns="0" rIns="0" bIns="0" rtlCol="0" anchor="ctr"/>
+          <a:lstStyle/>
+          <a:p>
+            <a:pPr indent="0" marL="0">
+              <a:buNone/>
+            </a:pPr>
+            <a:r>
+              <a:rPr lang="en-US" sz="1250" dirty="0">
                 <a:solidFill>
                   <a:srgbClr val="2A1618"/>
                 </a:solidFill>
@@ -5266,20 +5495,170 @@
                 <a:ea typeface="Calibri" pitchFamily="34" charset="-122"/>
                 <a:cs typeface="Calibri" pitchFamily="34" charset="-120"/>
               </a:rPr>
-              <a:t>3 planes (245): 11 mm. 5 planes (410): 4.8 mm.</a:t>
-            </a:r>
-            <a:endParaRPr lang="en-US" sz="1200" dirty="0"/>
-          </a:p>
-          <a:p>
-            <a:pPr marL="342900" indent="-342900">
-              <a:spcAft>
-                <a:spcPts val="800"/>
-              </a:spcAft>
-              <a:buSzPct val="100000"/>
-              <a:buChar char="•"/>
-            </a:pPr>
-            <a:r>
-              <a:rPr lang="en-US" sz="1200" dirty="0">
+              <a:t>2 conv blocks (32 filters each) plus pooling and dropout, identical to the measured (x,y) CNN.</a:t>
+            </a:r>
+            <a:endParaRPr lang="en-US" sz="1250" dirty="0"/>
+          </a:p>
+        </p:txBody>
+      </p:sp>
+      <p:sp>
+        <p:nvSpPr>
+          <p:cNvPr id="14" name="Shape 12"/>
+          <p:cNvSpPr/>
+          <p:nvPr/>
+        </p:nvSpPr>
+        <p:spPr>
+          <a:xfrm>
+            <a:off x="548640" y="3941064"/>
+            <a:ext cx="11091672" cy="1024128"/>
+          </a:xfrm>
+          <a:prstGeom prst="roundRect">
+            <a:avLst>
+              <a:gd name="adj" fmla="val 8036"/>
+            </a:avLst>
+          </a:prstGeom>
+          <a:solidFill>
+            <a:srgbClr val="FBF4F2"/>
+          </a:solidFill>
+          <a:ln w="12700">
+            <a:solidFill>
+              <a:srgbClr val="E7D6D1"/>
+            </a:solidFill>
+            <a:prstDash val="solid"/>
+          </a:ln>
+          <a:effectLst>
+            <a:outerShdw sx="100000" sy="100000" kx="0" ky="0" algn="bl" rotWithShape="0" blurRad="88900" dist="38100" dir="5400000">
+              <a:srgbClr val="7A5C5E">
+                <a:alpha val="18000"/>
+              </a:srgbClr>
+            </a:outerShdw>
+          </a:effectLst>
+        </p:spPr>
+      </p:sp>
+      <p:sp>
+        <p:nvSpPr>
+          <p:cNvPr id="15" name="Shape 13"/>
+          <p:cNvSpPr/>
+          <p:nvPr/>
+        </p:nvSpPr>
+        <p:spPr>
+          <a:xfrm>
+            <a:off x="777240" y="4197096"/>
+            <a:ext cx="512064" cy="512064"/>
+          </a:xfrm>
+          <a:prstGeom prst="ellipse">
+            <a:avLst/>
+          </a:prstGeom>
+          <a:solidFill>
+            <a:srgbClr val="BE0000"/>
+          </a:solidFill>
+          <a:ln/>
+        </p:spPr>
+      </p:sp>
+      <p:sp>
+        <p:nvSpPr>
+          <p:cNvPr id="16" name="Text 14"/>
+          <p:cNvSpPr/>
+          <p:nvPr/>
+        </p:nvSpPr>
+        <p:spPr>
+          <a:xfrm>
+            <a:off x="777240" y="4197096"/>
+            <a:ext cx="512064" cy="512064"/>
+          </a:xfrm>
+          <a:prstGeom prst="rect">
+            <a:avLst/>
+          </a:prstGeom>
+          <a:noFill/>
+          <a:ln/>
+        </p:spPr>
+        <p:txBody>
+          <a:bodyPr wrap="square" lIns="0" tIns="0" rIns="0" bIns="0" rtlCol="0" anchor="ctr"/>
+          <a:lstStyle/>
+          <a:p>
+            <a:pPr algn="ctr" indent="0" marL="0">
+              <a:buNone/>
+            </a:pPr>
+            <a:r>
+              <a:rPr lang="en-US" sz="2000" b="1" dirty="0">
+                <a:solidFill>
+                  <a:srgbClr val="FFFFFF"/>
+                </a:solidFill>
+                <a:latin typeface="Cambria" pitchFamily="34" charset="0"/>
+                <a:ea typeface="Cambria" pitchFamily="34" charset="-122"/>
+                <a:cs typeface="Cambria" pitchFamily="34" charset="-120"/>
+              </a:rPr>
+              <a:t>3</a:t>
+            </a:r>
+            <a:endParaRPr lang="en-US" sz="2000" dirty="0"/>
+          </a:p>
+        </p:txBody>
+      </p:sp>
+      <p:sp>
+        <p:nvSpPr>
+          <p:cNvPr id="17" name="Text 15"/>
+          <p:cNvSpPr/>
+          <p:nvPr/>
+        </p:nvSpPr>
+        <p:spPr>
+          <a:xfrm>
+            <a:off x="1508760" y="4087368"/>
+            <a:ext cx="2011680" cy="731520"/>
+          </a:xfrm>
+          <a:prstGeom prst="rect">
+            <a:avLst/>
+          </a:prstGeom>
+          <a:noFill/>
+          <a:ln/>
+        </p:spPr>
+        <p:txBody>
+          <a:bodyPr wrap="square" lIns="0" tIns="0" rIns="0" bIns="0" rtlCol="0" anchor="ctr"/>
+          <a:lstStyle/>
+          <a:p>
+            <a:pPr indent="0" marL="0">
+              <a:buNone/>
+            </a:pPr>
+            <a:r>
+              <a:rPr lang="en-US" sz="1700" b="1" dirty="0">
+                <a:solidFill>
+                  <a:srgbClr val="BE0000"/>
+                </a:solidFill>
+                <a:latin typeface="Cambria" pitchFamily="34" charset="0"/>
+                <a:ea typeface="Cambria" pitchFamily="34" charset="-122"/>
+                <a:cs typeface="Cambria" pitchFamily="34" charset="-120"/>
+              </a:rPr>
+              <a:t>Head</a:t>
+            </a:r>
+            <a:endParaRPr lang="en-US" sz="1700" dirty="0"/>
+          </a:p>
+        </p:txBody>
+      </p:sp>
+      <p:sp>
+        <p:nvSpPr>
+          <p:cNvPr id="18" name="Text 16"/>
+          <p:cNvSpPr/>
+          <p:nvPr/>
+        </p:nvSpPr>
+        <p:spPr>
+          <a:xfrm>
+            <a:off x="3611880" y="3995928"/>
+            <a:ext cx="7845552" cy="914400"/>
+          </a:xfrm>
+          <a:prstGeom prst="rect">
+            <a:avLst/>
+          </a:prstGeom>
+          <a:noFill/>
+          <a:ln/>
+        </p:spPr>
+        <p:txBody>
+          <a:bodyPr wrap="square" lIns="0" tIns="0" rIns="0" bIns="0" rtlCol="0" anchor="ctr"/>
+          <a:lstStyle/>
+          <a:p>
+            <a:pPr indent="0" marL="0">
+              <a:buNone/>
+            </a:pPr>
+            <a:r>
+              <a:rPr lang="en-US" sz="1250" dirty="0">
                 <a:solidFill>
                   <a:srgbClr val="2A1618"/>
                 </a:solidFill>
@@ -5287,20 +5666,170 @@
                 <a:ea typeface="Calibri" pitchFamily="34" charset="-122"/>
                 <a:cs typeface="Calibri" pitchFamily="34" charset="-120"/>
               </a:rPr>
-              <a:t>Plateau ~3.8 mm from 7 planes (about 570) on.</a:t>
-            </a:r>
-            <a:endParaRPr lang="en-US" sz="1200" dirty="0"/>
-          </a:p>
-          <a:p>
-            <a:pPr marL="342900" indent="-342900">
-              <a:spcAft>
-                <a:spcPts val="800"/>
-              </a:spcAft>
-              <a:buSzPct val="100000"/>
-              <a:buChar char="•"/>
-            </a:pPr>
-            <a:r>
-              <a:rPr lang="en-US" sz="1200" dirty="0">
+              <a:t>fc(3) plus regression to (x, y, z) in mm. Trained with an L2 coordinate loss, 60 epochs.</a:t>
+            </a:r>
+            <a:endParaRPr lang="en-US" sz="1250" dirty="0"/>
+          </a:p>
+        </p:txBody>
+      </p:sp>
+      <p:sp>
+        <p:nvSpPr>
+          <p:cNvPr id="19" name="Shape 17"/>
+          <p:cNvSpPr/>
+          <p:nvPr/>
+        </p:nvSpPr>
+        <p:spPr>
+          <a:xfrm>
+            <a:off x="548640" y="5111496"/>
+            <a:ext cx="11091672" cy="1024128"/>
+          </a:xfrm>
+          <a:prstGeom prst="roundRect">
+            <a:avLst>
+              <a:gd name="adj" fmla="val 8036"/>
+            </a:avLst>
+          </a:prstGeom>
+          <a:solidFill>
+            <a:srgbClr val="FBF4F2"/>
+          </a:solidFill>
+          <a:ln w="12700">
+            <a:solidFill>
+              <a:srgbClr val="E7D6D1"/>
+            </a:solidFill>
+            <a:prstDash val="solid"/>
+          </a:ln>
+          <a:effectLst>
+            <a:outerShdw sx="100000" sy="100000" kx="0" ky="0" algn="bl" rotWithShape="0" blurRad="88900" dist="38100" dir="5400000">
+              <a:srgbClr val="7A5C5E">
+                <a:alpha val="18000"/>
+              </a:srgbClr>
+            </a:outerShdw>
+          </a:effectLst>
+        </p:spPr>
+      </p:sp>
+      <p:sp>
+        <p:nvSpPr>
+          <p:cNvPr id="20" name="Shape 18"/>
+          <p:cNvSpPr/>
+          <p:nvPr/>
+        </p:nvSpPr>
+        <p:spPr>
+          <a:xfrm>
+            <a:off x="777240" y="5367528"/>
+            <a:ext cx="512064" cy="512064"/>
+          </a:xfrm>
+          <a:prstGeom prst="ellipse">
+            <a:avLst/>
+          </a:prstGeom>
+          <a:solidFill>
+            <a:srgbClr val="BE0000"/>
+          </a:solidFill>
+          <a:ln/>
+        </p:spPr>
+      </p:sp>
+      <p:sp>
+        <p:nvSpPr>
+          <p:cNvPr id="21" name="Text 19"/>
+          <p:cNvSpPr/>
+          <p:nvPr/>
+        </p:nvSpPr>
+        <p:spPr>
+          <a:xfrm>
+            <a:off x="777240" y="5367528"/>
+            <a:ext cx="512064" cy="512064"/>
+          </a:xfrm>
+          <a:prstGeom prst="rect">
+            <a:avLst/>
+          </a:prstGeom>
+          <a:noFill/>
+          <a:ln/>
+        </p:spPr>
+        <p:txBody>
+          <a:bodyPr wrap="square" lIns="0" tIns="0" rIns="0" bIns="0" rtlCol="0" anchor="ctr"/>
+          <a:lstStyle/>
+          <a:p>
+            <a:pPr algn="ctr" indent="0" marL="0">
+              <a:buNone/>
+            </a:pPr>
+            <a:r>
+              <a:rPr lang="en-US" sz="2000" b="1" dirty="0">
+                <a:solidFill>
+                  <a:srgbClr val="FFFFFF"/>
+                </a:solidFill>
+                <a:latin typeface="Cambria" pitchFamily="34" charset="0"/>
+                <a:ea typeface="Cambria" pitchFamily="34" charset="-122"/>
+                <a:cs typeface="Cambria" pitchFamily="34" charset="-120"/>
+              </a:rPr>
+              <a:t>4</a:t>
+            </a:r>
+            <a:endParaRPr lang="en-US" sz="2000" dirty="0"/>
+          </a:p>
+        </p:txBody>
+      </p:sp>
+      <p:sp>
+        <p:nvSpPr>
+          <p:cNvPr id="22" name="Text 20"/>
+          <p:cNvSpPr/>
+          <p:nvPr/>
+        </p:nvSpPr>
+        <p:spPr>
+          <a:xfrm>
+            <a:off x="1508760" y="5257800"/>
+            <a:ext cx="2011680" cy="731520"/>
+          </a:xfrm>
+          <a:prstGeom prst="rect">
+            <a:avLst/>
+          </a:prstGeom>
+          <a:noFill/>
+          <a:ln/>
+        </p:spPr>
+        <p:txBody>
+          <a:bodyPr wrap="square" lIns="0" tIns="0" rIns="0" bIns="0" rtlCol="0" anchor="ctr"/>
+          <a:lstStyle/>
+          <a:p>
+            <a:pPr indent="0" marL="0">
+              <a:buNone/>
+            </a:pPr>
+            <a:r>
+              <a:rPr lang="en-US" sz="1700" b="1" dirty="0">
+                <a:solidFill>
+                  <a:srgbClr val="BE0000"/>
+                </a:solidFill>
+                <a:latin typeface="Cambria" pitchFamily="34" charset="0"/>
+                <a:ea typeface="Cambria" pitchFamily="34" charset="-122"/>
+                <a:cs typeface="Cambria" pitchFamily="34" charset="-120"/>
+              </a:rPr>
+              <a:t>Evaluation</a:t>
+            </a:r>
+            <a:endParaRPr lang="en-US" sz="1700" dirty="0"/>
+          </a:p>
+        </p:txBody>
+      </p:sp>
+      <p:sp>
+        <p:nvSpPr>
+          <p:cNvPr id="23" name="Text 21"/>
+          <p:cNvSpPr/>
+          <p:nvPr/>
+        </p:nvSpPr>
+        <p:spPr>
+          <a:xfrm>
+            <a:off x="3611880" y="5166360"/>
+            <a:ext cx="7845552" cy="914400"/>
+          </a:xfrm>
+          <a:prstGeom prst="rect">
+            <a:avLst/>
+          </a:prstGeom>
+          <a:noFill/>
+          <a:ln/>
+        </p:spPr>
+        <p:txBody>
+          <a:bodyPr wrap="square" lIns="0" tIns="0" rIns="0" bIns="0" rtlCol="0" anchor="ctr"/>
+          <a:lstStyle/>
+          <a:p>
+            <a:pPr indent="0" marL="0">
+              <a:buNone/>
+            </a:pPr>
+            <a:r>
+              <a:rPr lang="en-US" sz="1250" dirty="0">
                 <a:solidFill>
                   <a:srgbClr val="2A1618"/>
                 </a:solidFill>
@@ -5308,30 +5837,9 @@
                 <a:ea typeface="Calibri" pitchFamily="34" charset="-122"/>
                 <a:cs typeface="Calibri" pitchFamily="34" charset="-120"/>
               </a:rPr>
-              <a:t>So it needs ~400 to 500 DISTINCT positions to localize; below ~250 it is poor.</a:t>
-            </a:r>
-            <a:endParaRPr lang="en-US" sz="1200" dirty="0"/>
-          </a:p>
-          <a:p>
-            <a:pPr marL="342900" indent="-342900">
-              <a:spcAft>
-                <a:spcPts val="800"/>
-              </a:spcAft>
-              <a:buSzPct val="100000"/>
-              <a:buChar char="•"/>
-            </a:pPr>
-            <a:r>
-              <a:rPr lang="en-US" sz="1200" dirty="0">
-                <a:solidFill>
-                  <a:srgbClr val="2A1618"/>
-                </a:solidFill>
-                <a:latin typeface="Calibri" pitchFamily="34" charset="0"/>
-                <a:ea typeface="Calibri" pitchFamily="34" charset="-122"/>
-                <a:cs typeface="Calibri" pitchFamily="34" charset="-120"/>
-              </a:rPr>
-              <a:t>Distinct positions matter, not raw sample count (see Part 3).</a:t>
-            </a:r>
-            <a:endParaRPr lang="en-US" sz="1200" dirty="0"/>
+              <a:t>8-fold hold-out by POSITION (every position predicted once, out-of-fold). Lateral = sqrt(dx^2+dy^2); depth = |dz|, reported separately so one axis cannot hide the other.</a:t>
+            </a:r>
+            <a:endParaRPr lang="en-US" sz="1250" dirty="0"/>
           </a:p>
         </p:txBody>
       </p:sp>
@@ -5400,7 +5908,7 @@
                 <a:ea typeface="Cambria" pitchFamily="34" charset="-122"/>
                 <a:cs typeface="Cambria" pitchFamily="34" charset="-120"/>
               </a:rPr>
-              <a:t>3D localization result (8-fold)</a:t>
+              <a:t>How much data does the CNN need?</a:t>
             </a:r>
             <a:endParaRPr lang="en-US" sz="2900" dirty="0"/>
           </a:p>
@@ -5439,26 +5947,50 @@
                 <a:ea typeface="Calibri" pitchFamily="34" charset="-122"/>
                 <a:cs typeface="Calibri" pitchFamily="34" charset="-120"/>
               </a:rPr>
-              <a:t>Every position predicted from a model that never saw it, lateral and depth separately</a:t>
+              <a:t>Train on more depth planes (more distinct positions) and watch the error fall</a:t>
             </a:r>
             <a:endParaRPr lang="en-US" sz="1400" dirty="0"/>
           </a:p>
         </p:txBody>
       </p:sp>
-      <p:sp>
-        <p:nvSpPr>
-          <p:cNvPr id="4" name="Shape 2"/>
-          <p:cNvSpPr/>
-          <p:nvPr/>
-        </p:nvSpPr>
-        <p:spPr>
-          <a:xfrm>
-            <a:off x="640080" y="1737360"/>
-            <a:ext cx="2514600" cy="1417320"/>
+      <p:pic>
+        <p:nvPicPr>
+          <p:cNvPr id="4" name="Image 0" descr="sim_depth_learning_curve.png">    </p:cNvPr>
+          <p:cNvPicPr>
+            <a:picLocks noChangeAspect="1"/>
+          </p:cNvPicPr>
+          <p:nvPr/>
+        </p:nvPicPr>
+        <p:blipFill>
+          <a:blip r:embed="rId1"/>
+          <a:stretch>
+            <a:fillRect/>
+          </a:stretch>
+        </p:blipFill>
+        <p:spPr>
+          <a:xfrm>
+            <a:off x="457200" y="1600200"/>
+            <a:ext cx="7223760" cy="4498848"/>
+          </a:xfrm>
+          <a:prstGeom prst="rect">
+            <a:avLst/>
+          </a:prstGeom>
+        </p:spPr>
+      </p:pic>
+      <p:sp>
+        <p:nvSpPr>
+          <p:cNvPr id="5" name="Shape 2"/>
+          <p:cNvSpPr/>
+          <p:nvPr/>
+        </p:nvSpPr>
+        <p:spPr>
+          <a:xfrm>
+            <a:off x="7863840" y="1600200"/>
+            <a:ext cx="3794760" cy="4498848"/>
           </a:xfrm>
           <a:prstGeom prst="roundRect">
             <a:avLst>
-              <a:gd name="adj" fmla="val 5806"/>
+              <a:gd name="adj" fmla="val 2169"/>
             </a:avLst>
           </a:prstGeom>
           <a:solidFill>
@@ -5481,30 +6013,30 @@
       </p:sp>
       <p:sp>
         <p:nvSpPr>
-          <p:cNvPr id="5" name="Text 3"/>
-          <p:cNvSpPr/>
-          <p:nvPr/>
-        </p:nvSpPr>
-        <p:spPr>
-          <a:xfrm>
-            <a:off x="640080" y="1901952"/>
-            <a:ext cx="2514600" cy="640080"/>
-          </a:xfrm>
-          <a:prstGeom prst="rect">
-            <a:avLst/>
-          </a:prstGeom>
-          <a:noFill/>
-          <a:ln/>
-        </p:spPr>
-        <p:txBody>
-          <a:bodyPr wrap="square" lIns="0" tIns="0" rIns="0" bIns="0" rtlCol="0" anchor="ctr"/>
-          <a:lstStyle/>
-          <a:p>
-            <a:pPr algn="ctr" indent="0" marL="0">
-              <a:buNone/>
-            </a:pPr>
-            <a:r>
-              <a:rPr lang="en-US" sz="3000" b="1" dirty="0">
+          <p:cNvPr id="6" name="Text 3"/>
+          <p:cNvSpPr/>
+          <p:nvPr/>
+        </p:nvSpPr>
+        <p:spPr>
+          <a:xfrm>
+            <a:off x="8092440" y="1783080"/>
+            <a:ext cx="3383280" cy="365760"/>
+          </a:xfrm>
+          <a:prstGeom prst="rect">
+            <a:avLst/>
+          </a:prstGeom>
+          <a:noFill/>
+          <a:ln/>
+        </p:spPr>
+        <p:txBody>
+          <a:bodyPr wrap="square" lIns="0" tIns="0" rIns="0" bIns="0" rtlCol="0" anchor="ctr"/>
+          <a:lstStyle/>
+          <a:p>
+            <a:pPr indent="0" marL="0">
+              <a:buNone/>
+            </a:pPr>
+            <a:r>
+              <a:rPr lang="en-US" sz="1600" b="1" dirty="0">
                 <a:solidFill>
                   <a:srgbClr val="BE0000"/>
                 </a:solidFill>
@@ -5512,538 +6044,22 @@
                 <a:ea typeface="Cambria" pitchFamily="34" charset="-122"/>
                 <a:cs typeface="Cambria" pitchFamily="34" charset="-120"/>
               </a:rPr>
-              <a:t>3.9 mm</a:t>
-            </a:r>
-            <a:endParaRPr lang="en-US" sz="3000" dirty="0"/>
-          </a:p>
-        </p:txBody>
-      </p:sp>
-      <p:sp>
-        <p:nvSpPr>
-          <p:cNvPr id="6" name="Text 4"/>
-          <p:cNvSpPr/>
-          <p:nvPr/>
-        </p:nvSpPr>
-        <p:spPr>
-          <a:xfrm>
-            <a:off x="731520" y="2606040"/>
-            <a:ext cx="2331720" cy="457200"/>
-          </a:xfrm>
-          <a:prstGeom prst="rect">
-            <a:avLst/>
-          </a:prstGeom>
-          <a:noFill/>
-          <a:ln/>
-        </p:spPr>
-        <p:txBody>
-          <a:bodyPr wrap="square" lIns="0" tIns="0" rIns="0" bIns="0" rtlCol="0" anchor="ctr"/>
-          <a:lstStyle/>
-          <a:p>
-            <a:pPr algn="ctr" indent="0" marL="0">
-              <a:buNone/>
-            </a:pPr>
-            <a:r>
-              <a:rPr lang="en-US" sz="1250" dirty="0">
-                <a:solidFill>
-                  <a:srgbClr val="836A68"/>
-                </a:solidFill>
-                <a:latin typeface="Calibri" pitchFamily="34" charset="0"/>
-                <a:ea typeface="Calibri" pitchFamily="34" charset="-122"/>
-                <a:cs typeface="Calibri" pitchFamily="34" charset="-120"/>
-              </a:rPr>
-              <a:t>lateral (xy) median</a:t>
-            </a:r>
-            <a:endParaRPr lang="en-US" sz="1250" dirty="0"/>
-          </a:p>
-          <a:p>
-            <a:pPr algn="ctr" indent="0" marL="0">
-              <a:buNone/>
-            </a:pPr>
-            <a:r>
-              <a:rPr lang="en-US" sz="1250" dirty="0">
-                <a:solidFill>
-                  <a:srgbClr val="836A68"/>
-                </a:solidFill>
-                <a:latin typeface="Calibri" pitchFamily="34" charset="0"/>
-                <a:ea typeface="Calibri" pitchFamily="34" charset="-122"/>
-                <a:cs typeface="Calibri" pitchFamily="34" charset="-120"/>
-              </a:rPr>
-              <a:t>vs 36.5 mm chance</a:t>
-            </a:r>
-            <a:endParaRPr lang="en-US" sz="1250" dirty="0"/>
-          </a:p>
-        </p:txBody>
-      </p:sp>
-      <p:sp>
-        <p:nvSpPr>
-          <p:cNvPr id="7" name="Shape 5"/>
-          <p:cNvSpPr/>
-          <p:nvPr/>
-        </p:nvSpPr>
-        <p:spPr>
-          <a:xfrm>
-            <a:off x="3337560" y="1737360"/>
-            <a:ext cx="2514600" cy="1417320"/>
-          </a:xfrm>
-          <a:prstGeom prst="roundRect">
-            <a:avLst>
-              <a:gd name="adj" fmla="val 5806"/>
-            </a:avLst>
-          </a:prstGeom>
-          <a:solidFill>
-            <a:srgbClr val="FBF4F2"/>
-          </a:solidFill>
-          <a:ln w="12700">
-            <a:solidFill>
-              <a:srgbClr val="E7D6D1"/>
-            </a:solidFill>
-            <a:prstDash val="solid"/>
-          </a:ln>
-          <a:effectLst>
-            <a:outerShdw sx="100000" sy="100000" kx="0" ky="0" algn="bl" rotWithShape="0" blurRad="88900" dist="38100" dir="5400000">
-              <a:srgbClr val="7A5C5E">
-                <a:alpha val="18000"/>
-              </a:srgbClr>
-            </a:outerShdw>
-          </a:effectLst>
-        </p:spPr>
-      </p:sp>
-      <p:sp>
-        <p:nvSpPr>
-          <p:cNvPr id="8" name="Text 6"/>
-          <p:cNvSpPr/>
-          <p:nvPr/>
-        </p:nvSpPr>
-        <p:spPr>
-          <a:xfrm>
-            <a:off x="3337560" y="1901952"/>
-            <a:ext cx="2514600" cy="640080"/>
-          </a:xfrm>
-          <a:prstGeom prst="rect">
-            <a:avLst/>
-          </a:prstGeom>
-          <a:noFill/>
-          <a:ln/>
-        </p:spPr>
-        <p:txBody>
-          <a:bodyPr wrap="square" lIns="0" tIns="0" rIns="0" bIns="0" rtlCol="0" anchor="ctr"/>
-          <a:lstStyle/>
-          <a:p>
-            <a:pPr algn="ctr" indent="0" marL="0">
-              <a:buNone/>
-            </a:pPr>
-            <a:r>
-              <a:rPr lang="en-US" sz="3000" b="1" dirty="0">
-                <a:solidFill>
-                  <a:srgbClr val="C0564A"/>
-                </a:solidFill>
-                <a:latin typeface="Cambria" pitchFamily="34" charset="0"/>
-                <a:ea typeface="Cambria" pitchFamily="34" charset="-122"/>
-                <a:cs typeface="Cambria" pitchFamily="34" charset="-120"/>
-              </a:rPr>
-              <a:t>2.1 mm</a:t>
-            </a:r>
-            <a:endParaRPr lang="en-US" sz="3000" dirty="0"/>
-          </a:p>
-        </p:txBody>
-      </p:sp>
-      <p:sp>
-        <p:nvSpPr>
-          <p:cNvPr id="9" name="Text 7"/>
-          <p:cNvSpPr/>
-          <p:nvPr/>
-        </p:nvSpPr>
-        <p:spPr>
-          <a:xfrm>
-            <a:off x="3429000" y="2606040"/>
-            <a:ext cx="2331720" cy="457200"/>
-          </a:xfrm>
-          <a:prstGeom prst="rect">
-            <a:avLst/>
-          </a:prstGeom>
-          <a:noFill/>
-          <a:ln/>
-        </p:spPr>
-        <p:txBody>
-          <a:bodyPr wrap="square" lIns="0" tIns="0" rIns="0" bIns="0" rtlCol="0" anchor="ctr"/>
-          <a:lstStyle/>
-          <a:p>
-            <a:pPr algn="ctr" indent="0" marL="0">
-              <a:buNone/>
-            </a:pPr>
-            <a:r>
-              <a:rPr lang="en-US" sz="1250" dirty="0">
-                <a:solidFill>
-                  <a:srgbClr val="836A68"/>
-                </a:solidFill>
-                <a:latin typeface="Calibri" pitchFamily="34" charset="0"/>
-                <a:ea typeface="Calibri" pitchFamily="34" charset="-122"/>
-                <a:cs typeface="Calibri" pitchFamily="34" charset="-120"/>
-              </a:rPr>
-              <a:t>depth (z) median</a:t>
-            </a:r>
-            <a:endParaRPr lang="en-US" sz="1250" dirty="0"/>
-          </a:p>
-          <a:p>
-            <a:pPr algn="ctr" indent="0" marL="0">
-              <a:buNone/>
-            </a:pPr>
-            <a:r>
-              <a:rPr lang="en-US" sz="1250" dirty="0">
-                <a:solidFill>
-                  <a:srgbClr val="836A68"/>
-                </a:solidFill>
-                <a:latin typeface="Calibri" pitchFamily="34" charset="0"/>
-                <a:ea typeface="Calibri" pitchFamily="34" charset="-122"/>
-                <a:cs typeface="Calibri" pitchFamily="34" charset="-120"/>
-              </a:rPr>
-              <a:t>vs 16.3 mm chance</a:t>
-            </a:r>
-            <a:endParaRPr lang="en-US" sz="1250" dirty="0"/>
-          </a:p>
-        </p:txBody>
-      </p:sp>
-      <p:sp>
-        <p:nvSpPr>
-          <p:cNvPr id="10" name="Shape 8"/>
-          <p:cNvSpPr/>
-          <p:nvPr/>
-        </p:nvSpPr>
-        <p:spPr>
-          <a:xfrm>
-            <a:off x="6035040" y="1737360"/>
-            <a:ext cx="2514600" cy="1417320"/>
-          </a:xfrm>
-          <a:prstGeom prst="roundRect">
-            <a:avLst>
-              <a:gd name="adj" fmla="val 5806"/>
-            </a:avLst>
-          </a:prstGeom>
-          <a:solidFill>
-            <a:srgbClr val="FBF4F2"/>
-          </a:solidFill>
-          <a:ln w="12700">
-            <a:solidFill>
-              <a:srgbClr val="E7D6D1"/>
-            </a:solidFill>
-            <a:prstDash val="solid"/>
-          </a:ln>
-          <a:effectLst>
-            <a:outerShdw sx="100000" sy="100000" kx="0" ky="0" algn="bl" rotWithShape="0" blurRad="88900" dist="38100" dir="5400000">
-              <a:srgbClr val="7A5C5E">
-                <a:alpha val="18000"/>
-              </a:srgbClr>
-            </a:outerShdw>
-          </a:effectLst>
-        </p:spPr>
-      </p:sp>
-      <p:sp>
-        <p:nvSpPr>
-          <p:cNvPr id="11" name="Text 9"/>
-          <p:cNvSpPr/>
-          <p:nvPr/>
-        </p:nvSpPr>
-        <p:spPr>
-          <a:xfrm>
-            <a:off x="6035040" y="1901952"/>
-            <a:ext cx="2514600" cy="640080"/>
-          </a:xfrm>
-          <a:prstGeom prst="rect">
-            <a:avLst/>
-          </a:prstGeom>
-          <a:noFill/>
-          <a:ln/>
-        </p:spPr>
-        <p:txBody>
-          <a:bodyPr wrap="square" lIns="0" tIns="0" rIns="0" bIns="0" rtlCol="0" anchor="ctr"/>
-          <a:lstStyle/>
-          <a:p>
-            <a:pPr algn="ctr" indent="0" marL="0">
-              <a:buNone/>
-            </a:pPr>
-            <a:r>
-              <a:rPr lang="en-US" sz="3000" b="1" dirty="0">
-                <a:solidFill>
-                  <a:srgbClr val="8E1010"/>
-                </a:solidFill>
-                <a:latin typeface="Cambria" pitchFamily="34" charset="0"/>
-                <a:ea typeface="Cambria" pitchFamily="34" charset="-122"/>
-                <a:cs typeface="Cambria" pitchFamily="34" charset="-120"/>
-              </a:rPr>
-              <a:t>93 %</a:t>
-            </a:r>
-            <a:endParaRPr lang="en-US" sz="3000" dirty="0"/>
-          </a:p>
-        </p:txBody>
-      </p:sp>
-      <p:sp>
-        <p:nvSpPr>
-          <p:cNvPr id="12" name="Text 10"/>
-          <p:cNvSpPr/>
-          <p:nvPr/>
-        </p:nvSpPr>
-        <p:spPr>
-          <a:xfrm>
-            <a:off x="6126480" y="2606040"/>
-            <a:ext cx="2331720" cy="457200"/>
-          </a:xfrm>
-          <a:prstGeom prst="rect">
-            <a:avLst/>
-          </a:prstGeom>
-          <a:noFill/>
-          <a:ln/>
-        </p:spPr>
-        <p:txBody>
-          <a:bodyPr wrap="square" lIns="0" tIns="0" rIns="0" bIns="0" rtlCol="0" anchor="ctr"/>
-          <a:lstStyle/>
-          <a:p>
-            <a:pPr algn="ctr" indent="0" marL="0">
-              <a:buNone/>
-            </a:pPr>
-            <a:r>
-              <a:rPr lang="en-US" sz="1250" dirty="0">
-                <a:solidFill>
-                  <a:srgbClr val="836A68"/>
-                </a:solidFill>
-                <a:latin typeface="Calibri" pitchFamily="34" charset="0"/>
-                <a:ea typeface="Calibri" pitchFamily="34" charset="-122"/>
-                <a:cs typeface="Calibri" pitchFamily="34" charset="-120"/>
-              </a:rPr>
-              <a:t>of positions within</a:t>
-            </a:r>
-            <a:endParaRPr lang="en-US" sz="1250" dirty="0"/>
-          </a:p>
-          <a:p>
-            <a:pPr algn="ctr" indent="0" marL="0">
-              <a:buNone/>
-            </a:pPr>
-            <a:r>
-              <a:rPr lang="en-US" sz="1250" dirty="0">
-                <a:solidFill>
-                  <a:srgbClr val="836A68"/>
-                </a:solidFill>
-                <a:latin typeface="Calibri" pitchFamily="34" charset="0"/>
-                <a:ea typeface="Calibri" pitchFamily="34" charset="-122"/>
-                <a:cs typeface="Calibri" pitchFamily="34" charset="-120"/>
-              </a:rPr>
-              <a:t>10 mm laterally</a:t>
-            </a:r>
-            <a:endParaRPr lang="en-US" sz="1250" dirty="0"/>
-          </a:p>
-        </p:txBody>
-      </p:sp>
-      <p:sp>
-        <p:nvSpPr>
-          <p:cNvPr id="13" name="Shape 11"/>
-          <p:cNvSpPr/>
-          <p:nvPr/>
-        </p:nvSpPr>
-        <p:spPr>
-          <a:xfrm>
-            <a:off x="8732520" y="1737360"/>
-            <a:ext cx="2514600" cy="1417320"/>
-          </a:xfrm>
-          <a:prstGeom prst="roundRect">
-            <a:avLst>
-              <a:gd name="adj" fmla="val 5806"/>
-            </a:avLst>
-          </a:prstGeom>
-          <a:solidFill>
-            <a:srgbClr val="FBF4F2"/>
-          </a:solidFill>
-          <a:ln w="12700">
-            <a:solidFill>
-              <a:srgbClr val="E7D6D1"/>
-            </a:solidFill>
-            <a:prstDash val="solid"/>
-          </a:ln>
-          <a:effectLst>
-            <a:outerShdw sx="100000" sy="100000" kx="0" ky="0" algn="bl" rotWithShape="0" blurRad="88900" dist="38100" dir="5400000">
-              <a:srgbClr val="7A5C5E">
-                <a:alpha val="18000"/>
-              </a:srgbClr>
-            </a:outerShdw>
-          </a:effectLst>
-        </p:spPr>
-      </p:sp>
-      <p:sp>
-        <p:nvSpPr>
-          <p:cNvPr id="14" name="Text 12"/>
-          <p:cNvSpPr/>
-          <p:nvPr/>
-        </p:nvSpPr>
-        <p:spPr>
-          <a:xfrm>
-            <a:off x="8732520" y="1901952"/>
-            <a:ext cx="2514600" cy="640080"/>
-          </a:xfrm>
-          <a:prstGeom prst="rect">
-            <a:avLst/>
-          </a:prstGeom>
-          <a:noFill/>
-          <a:ln/>
-        </p:spPr>
-        <p:txBody>
-          <a:bodyPr wrap="square" lIns="0" tIns="0" rIns="0" bIns="0" rtlCol="0" anchor="ctr"/>
-          <a:lstStyle/>
-          <a:p>
-            <a:pPr algn="ctr" indent="0" marL="0">
-              <a:buNone/>
-            </a:pPr>
-            <a:r>
-              <a:rPr lang="en-US" sz="3000" b="1" dirty="0">
-                <a:solidFill>
-                  <a:srgbClr val="C8890B"/>
-                </a:solidFill>
-                <a:latin typeface="Cambria" pitchFamily="34" charset="0"/>
-                <a:ea typeface="Cambria" pitchFamily="34" charset="-122"/>
-                <a:cs typeface="Cambria" pitchFamily="34" charset="-120"/>
-              </a:rPr>
-              <a:t>3.6 / 2.1</a:t>
-            </a:r>
-            <a:endParaRPr lang="en-US" sz="3000" dirty="0"/>
-          </a:p>
-        </p:txBody>
-      </p:sp>
-      <p:sp>
-        <p:nvSpPr>
-          <p:cNvPr id="15" name="Text 13"/>
-          <p:cNvSpPr/>
-          <p:nvPr/>
-        </p:nvSpPr>
-        <p:spPr>
-          <a:xfrm>
-            <a:off x="8823960" y="2606040"/>
-            <a:ext cx="2331720" cy="457200"/>
-          </a:xfrm>
-          <a:prstGeom prst="rect">
-            <a:avLst/>
-          </a:prstGeom>
-          <a:noFill/>
-          <a:ln/>
-        </p:spPr>
-        <p:txBody>
-          <a:bodyPr wrap="square" lIns="0" tIns="0" rIns="0" bIns="0" rtlCol="0" anchor="ctr"/>
-          <a:lstStyle/>
-          <a:p>
-            <a:pPr algn="ctr" indent="0" marL="0">
-              <a:buNone/>
-            </a:pPr>
-            <a:r>
-              <a:rPr lang="en-US" sz="1250" dirty="0">
-                <a:solidFill>
-                  <a:srgbClr val="836A68"/>
-                </a:solidFill>
-                <a:latin typeface="Calibri" pitchFamily="34" charset="0"/>
-                <a:ea typeface="Calibri" pitchFamily="34" charset="-122"/>
-                <a:cs typeface="Calibri" pitchFamily="34" charset="-120"/>
-              </a:rPr>
-              <a:t>beet (dielectric)</a:t>
-            </a:r>
-            <a:endParaRPr lang="en-US" sz="1250" dirty="0"/>
-          </a:p>
-          <a:p>
-            <a:pPr algn="ctr" indent="0" marL="0">
-              <a:buNone/>
-            </a:pPr>
-            <a:r>
-              <a:rPr lang="en-US" sz="1250" dirty="0">
-                <a:solidFill>
-                  <a:srgbClr val="836A68"/>
-                </a:solidFill>
-                <a:latin typeface="Calibri" pitchFamily="34" charset="0"/>
-                <a:ea typeface="Calibri" pitchFamily="34" charset="-122"/>
-                <a:cs typeface="Calibri" pitchFamily="34" charset="-120"/>
-              </a:rPr>
-              <a:t>xy / z, same as metal</a:t>
-            </a:r>
-            <a:endParaRPr lang="en-US" sz="1250" dirty="0"/>
-          </a:p>
-        </p:txBody>
-      </p:sp>
-      <p:sp>
-        <p:nvSpPr>
-          <p:cNvPr id="16" name="Shape 14"/>
-          <p:cNvSpPr/>
-          <p:nvPr/>
-        </p:nvSpPr>
-        <p:spPr>
-          <a:xfrm>
-            <a:off x="640080" y="3429000"/>
-            <a:ext cx="10607040" cy="2697480"/>
-          </a:xfrm>
-          <a:prstGeom prst="roundRect">
-            <a:avLst>
-              <a:gd name="adj" fmla="val 3051"/>
-            </a:avLst>
-          </a:prstGeom>
-          <a:solidFill>
-            <a:srgbClr val="FBF4F2"/>
-          </a:solidFill>
-          <a:ln w="12700">
-            <a:solidFill>
-              <a:srgbClr val="E7D6D1"/>
-            </a:solidFill>
-            <a:prstDash val="solid"/>
-          </a:ln>
-          <a:effectLst>
-            <a:outerShdw sx="100000" sy="100000" kx="0" ky="0" algn="bl" rotWithShape="0" blurRad="88900" dist="38100" dir="5400000">
-              <a:srgbClr val="7A5C5E">
-                <a:alpha val="18000"/>
-              </a:srgbClr>
-            </a:outerShdw>
-          </a:effectLst>
-        </p:spPr>
-      </p:sp>
-      <p:sp>
-        <p:nvSpPr>
-          <p:cNvPr id="17" name="Text 15"/>
-          <p:cNvSpPr/>
-          <p:nvPr/>
-        </p:nvSpPr>
-        <p:spPr>
-          <a:xfrm>
-            <a:off x="914400" y="3611880"/>
-            <a:ext cx="9144000" cy="365760"/>
-          </a:xfrm>
-          <a:prstGeom prst="rect">
-            <a:avLst/>
-          </a:prstGeom>
-          <a:noFill/>
-          <a:ln/>
-        </p:spPr>
-        <p:txBody>
-          <a:bodyPr wrap="square" lIns="0" tIns="0" rIns="0" bIns="0" rtlCol="0" anchor="ctr"/>
-          <a:lstStyle/>
-          <a:p>
-            <a:pPr indent="0" marL="0">
-              <a:buNone/>
-            </a:pPr>
-            <a:r>
-              <a:rPr lang="en-US" sz="1700" b="1" dirty="0">
-                <a:solidFill>
-                  <a:srgbClr val="BE0000"/>
-                </a:solidFill>
-                <a:latin typeface="Cambria" pitchFamily="34" charset="0"/>
-                <a:ea typeface="Cambria" pitchFamily="34" charset="-122"/>
-                <a:cs typeface="Cambria" pitchFamily="34" charset="-120"/>
-              </a:rPr>
-              <a:t>What this establishes</a:t>
-            </a:r>
-            <a:endParaRPr lang="en-US" sz="1700" dirty="0"/>
-          </a:p>
-        </p:txBody>
-      </p:sp>
-      <p:sp>
-        <p:nvSpPr>
-          <p:cNvPr id="18" name="Text 16"/>
-          <p:cNvSpPr/>
-          <p:nvPr/>
-        </p:nvSpPr>
-        <p:spPr>
-          <a:xfrm>
-            <a:off x="914400" y="4114800"/>
-            <a:ext cx="10332720" cy="1920240"/>
+              <a:t>The threshold</a:t>
+            </a:r>
+            <a:endParaRPr lang="en-US" sz="1600" dirty="0"/>
+          </a:p>
+        </p:txBody>
+      </p:sp>
+      <p:sp>
+        <p:nvSpPr>
+          <p:cNvPr id="7" name="Text 4"/>
+          <p:cNvSpPr/>
+          <p:nvPr/>
+        </p:nvSpPr>
+        <p:spPr>
+          <a:xfrm>
+            <a:off x="8092440" y="2286000"/>
+            <a:ext cx="3383280" cy="3657600"/>
           </a:xfrm>
           <a:prstGeom prst="rect">
             <a:avLst/>
@@ -6063,7 +6079,7 @@
               <a:buChar char="•"/>
             </a:pPr>
             <a:r>
-              <a:rPr lang="en-US" sz="1350" dirty="0">
+              <a:rPr lang="en-US" sz="1200" dirty="0">
                 <a:solidFill>
                   <a:srgbClr val="2A1618"/>
                 </a:solidFill>
@@ -6071,9 +6087,9 @@
                 <a:ea typeface="Calibri" pitchFamily="34" charset="-122"/>
                 <a:cs typeface="Calibri" pitchFamily="34" charset="-120"/>
               </a:rPr>
-              <a:t>Depth is NOT the weak axis. With fine depth sampling and full-band frequency, z resolves to ~2 mm, better than the lateral k-NN floor.</a:t>
-            </a:r>
-            <a:endParaRPr lang="en-US" sz="1350" dirty="0"/>
+              <a:t>1 depth plane (82 positions): 33 mm, about chance. The conv net cannot train.</a:t>
+            </a:r>
+            <a:endParaRPr lang="en-US" sz="1200" dirty="0"/>
           </a:p>
           <a:p>
             <a:pPr marL="342900" indent="-342900">
@@ -6084,7 +6100,7 @@
               <a:buChar char="•"/>
             </a:pPr>
             <a:r>
-              <a:rPr lang="en-US" sz="1350" dirty="0">
+              <a:rPr lang="en-US" sz="1200" dirty="0">
                 <a:solidFill>
                   <a:srgbClr val="2A1618"/>
                 </a:solidFill>
@@ -6092,9 +6108,9 @@
                 <a:ea typeface="Calibri" pitchFamily="34" charset="-122"/>
                 <a:cs typeface="Calibri" pitchFamily="34" charset="-120"/>
               </a:rPr>
-              <a:t>A dielectric (beet) tumor localizes identically to metal (3.6 / 2.1 mm). In the noiseless sim the ~19 percent weaker contrast costs nothing.</a:t>
-            </a:r>
-            <a:endParaRPr lang="en-US" sz="1350" dirty="0"/>
+              <a:t>3 planes (245): 11 mm. 5 planes (410): 4.8 mm.</a:t>
+            </a:r>
+            <a:endParaRPr lang="en-US" sz="1200" dirty="0"/>
           </a:p>
           <a:p>
             <a:pPr marL="342900" indent="-342900">
@@ -6105,7 +6121,7 @@
               <a:buChar char="•"/>
             </a:pPr>
             <a:r>
-              <a:rPr lang="en-US" sz="1350" dirty="0">
+              <a:rPr lang="en-US" sz="1200" dirty="0">
                 <a:solidFill>
                   <a:srgbClr val="2A1618"/>
                 </a:solidFill>
@@ -6113,9 +6129,51 @@
                 <a:ea typeface="Calibri" pitchFamily="34" charset="-122"/>
                 <a:cs typeface="Calibri" pitchFamily="34" charset="-120"/>
               </a:rPr>
-              <a:t>Chance is 36 mm laterally / 16 mm in depth, so the model is about 10x better than guessing the centre on both axes.</a:t>
-            </a:r>
-            <a:endParaRPr lang="en-US" sz="1350" dirty="0"/>
+              <a:t>Plateau ~3.8 mm from 7 planes (about 570) on.</a:t>
+            </a:r>
+            <a:endParaRPr lang="en-US" sz="1200" dirty="0"/>
+          </a:p>
+          <a:p>
+            <a:pPr marL="342900" indent="-342900">
+              <a:spcAft>
+                <a:spcPts val="800"/>
+              </a:spcAft>
+              <a:buSzPct val="100000"/>
+              <a:buChar char="•"/>
+            </a:pPr>
+            <a:r>
+              <a:rPr lang="en-US" sz="1200" dirty="0">
+                <a:solidFill>
+                  <a:srgbClr val="2A1618"/>
+                </a:solidFill>
+                <a:latin typeface="Calibri" pitchFamily="34" charset="0"/>
+                <a:ea typeface="Calibri" pitchFamily="34" charset="-122"/>
+                <a:cs typeface="Calibri" pitchFamily="34" charset="-120"/>
+              </a:rPr>
+              <a:t>So it needs ~400 to 500 DISTINCT positions to localize; below ~250 it is poor.</a:t>
+            </a:r>
+            <a:endParaRPr lang="en-US" sz="1200" dirty="0"/>
+          </a:p>
+          <a:p>
+            <a:pPr marL="342900" indent="-342900">
+              <a:spcAft>
+                <a:spcPts val="800"/>
+              </a:spcAft>
+              <a:buSzPct val="100000"/>
+              <a:buChar char="•"/>
+            </a:pPr>
+            <a:r>
+              <a:rPr lang="en-US" sz="1200" dirty="0">
+                <a:solidFill>
+                  <a:srgbClr val="2A1618"/>
+                </a:solidFill>
+                <a:latin typeface="Calibri" pitchFamily="34" charset="0"/>
+                <a:ea typeface="Calibri" pitchFamily="34" charset="-122"/>
+                <a:cs typeface="Calibri" pitchFamily="34" charset="-120"/>
+              </a:rPr>
+              <a:t>Distinct positions matter, not raw sample count (see Part 3).</a:t>
+            </a:r>
+            <a:endParaRPr lang="en-US" sz="1200" dirty="0"/>
           </a:p>
         </p:txBody>
       </p:sp>
@@ -6184,7 +6242,7 @@
                 <a:ea typeface="Cambria" pitchFamily="34" charset="-122"/>
                 <a:cs typeface="Cambria" pitchFamily="34" charset="-120"/>
               </a:rPr>
-              <a:t>Predicting an unseen depth plane</a:t>
+              <a:t>3D localization result (8-fold)</a:t>
             </a:r>
             <a:endParaRPr lang="en-US" sz="2900" dirty="0"/>
           </a:p>
@@ -6223,50 +6281,26 @@
                 <a:ea typeface="Calibri" pitchFamily="34" charset="-122"/>
                 <a:cs typeface="Calibri" pitchFamily="34" charset="-120"/>
               </a:rPr>
-              <a:t>Leave one whole depth out; interior depths interpolate, only the outer edge depths fail</a:t>
+              <a:t>Every position predicted from a model that never saw it, lateral and depth separately</a:t>
             </a:r>
             <a:endParaRPr lang="en-US" sz="1400" dirty="0"/>
           </a:p>
         </p:txBody>
       </p:sp>
-      <p:pic>
-        <p:nvPicPr>
-          <p:cNvPr id="4" name="Image 0" descr="sim_depth_lopo.png">    </p:cNvPr>
-          <p:cNvPicPr>
-            <a:picLocks noChangeAspect="1"/>
-          </p:cNvPicPr>
-          <p:nvPr/>
-        </p:nvPicPr>
-        <p:blipFill>
-          <a:blip r:embed="rId1"/>
-          <a:stretch>
-            <a:fillRect/>
-          </a:stretch>
-        </p:blipFill>
-        <p:spPr>
-          <a:xfrm>
-            <a:off x="365760" y="1600200"/>
-            <a:ext cx="8595360" cy="3566160"/>
-          </a:xfrm>
-          <a:prstGeom prst="rect">
-            <a:avLst/>
-          </a:prstGeom>
-        </p:spPr>
-      </p:pic>
-      <p:sp>
-        <p:nvSpPr>
-          <p:cNvPr id="5" name="Shape 2"/>
-          <p:cNvSpPr/>
-          <p:nvPr/>
-        </p:nvSpPr>
-        <p:spPr>
-          <a:xfrm>
-            <a:off x="9098280" y="1600200"/>
-            <a:ext cx="2651760" cy="3566160"/>
+      <p:sp>
+        <p:nvSpPr>
+          <p:cNvPr id="4" name="Shape 2"/>
+          <p:cNvSpPr/>
+          <p:nvPr/>
+        </p:nvSpPr>
+        <p:spPr>
+          <a:xfrm>
+            <a:off x="640080" y="1737360"/>
+            <a:ext cx="2514600" cy="1417320"/>
           </a:xfrm>
           <a:prstGeom prst="roundRect">
             <a:avLst>
-              <a:gd name="adj" fmla="val 3103"/>
+              <a:gd name="adj" fmla="val 5806"/>
             </a:avLst>
           </a:prstGeom>
           <a:solidFill>
@@ -6289,30 +6323,30 @@
       </p:sp>
       <p:sp>
         <p:nvSpPr>
-          <p:cNvPr id="6" name="Text 3"/>
-          <p:cNvSpPr/>
-          <p:nvPr/>
-        </p:nvSpPr>
-        <p:spPr>
-          <a:xfrm>
-            <a:off x="9281160" y="1737360"/>
-            <a:ext cx="2377440" cy="548640"/>
-          </a:xfrm>
-          <a:prstGeom prst="rect">
-            <a:avLst/>
-          </a:prstGeom>
-          <a:noFill/>
-          <a:ln/>
-        </p:spPr>
-        <p:txBody>
-          <a:bodyPr wrap="square" lIns="0" tIns="0" rIns="0" bIns="0" rtlCol="0" anchor="ctr"/>
-          <a:lstStyle/>
-          <a:p>
-            <a:pPr indent="0" marL="0">
-              <a:buNone/>
-            </a:pPr>
-            <a:r>
-              <a:rPr lang="en-US" sz="1400" b="1" dirty="0">
+          <p:cNvPr id="5" name="Text 3"/>
+          <p:cNvSpPr/>
+          <p:nvPr/>
+        </p:nvSpPr>
+        <p:spPr>
+          <a:xfrm>
+            <a:off x="640080" y="1901952"/>
+            <a:ext cx="2514600" cy="640080"/>
+          </a:xfrm>
+          <a:prstGeom prst="rect">
+            <a:avLst/>
+          </a:prstGeom>
+          <a:noFill/>
+          <a:ln/>
+        </p:spPr>
+        <p:txBody>
+          <a:bodyPr wrap="square" lIns="0" tIns="0" rIns="0" bIns="0" rtlCol="0" anchor="ctr"/>
+          <a:lstStyle/>
+          <a:p>
+            <a:pPr algn="ctr" indent="0" marL="0">
+              <a:buNone/>
+            </a:pPr>
+            <a:r>
+              <a:rPr lang="en-US" sz="3000" b="1" dirty="0">
                 <a:solidFill>
                   <a:srgbClr val="BE0000"/>
                 </a:solidFill>
@@ -6320,22 +6354,538 @@
                 <a:ea typeface="Cambria" pitchFamily="34" charset="-122"/>
                 <a:cs typeface="Cambria" pitchFamily="34" charset="-120"/>
               </a:rPr>
-              <a:t>Range-bound, not model-bound</a:t>
-            </a:r>
-            <a:endParaRPr lang="en-US" sz="1400" dirty="0"/>
-          </a:p>
-        </p:txBody>
-      </p:sp>
-      <p:sp>
-        <p:nvSpPr>
-          <p:cNvPr id="7" name="Text 4"/>
-          <p:cNvSpPr/>
-          <p:nvPr/>
-        </p:nvSpPr>
-        <p:spPr>
-          <a:xfrm>
-            <a:off x="9281160" y="2377440"/>
-            <a:ext cx="2377440" cy="2743200"/>
+              <a:t>3.9 mm</a:t>
+            </a:r>
+            <a:endParaRPr lang="en-US" sz="3000" dirty="0"/>
+          </a:p>
+        </p:txBody>
+      </p:sp>
+      <p:sp>
+        <p:nvSpPr>
+          <p:cNvPr id="6" name="Text 4"/>
+          <p:cNvSpPr/>
+          <p:nvPr/>
+        </p:nvSpPr>
+        <p:spPr>
+          <a:xfrm>
+            <a:off x="731520" y="2606040"/>
+            <a:ext cx="2331720" cy="457200"/>
+          </a:xfrm>
+          <a:prstGeom prst="rect">
+            <a:avLst/>
+          </a:prstGeom>
+          <a:noFill/>
+          <a:ln/>
+        </p:spPr>
+        <p:txBody>
+          <a:bodyPr wrap="square" lIns="0" tIns="0" rIns="0" bIns="0" rtlCol="0" anchor="ctr"/>
+          <a:lstStyle/>
+          <a:p>
+            <a:pPr algn="ctr" indent="0" marL="0">
+              <a:buNone/>
+            </a:pPr>
+            <a:r>
+              <a:rPr lang="en-US" sz="1250" dirty="0">
+                <a:solidFill>
+                  <a:srgbClr val="836A68"/>
+                </a:solidFill>
+                <a:latin typeface="Calibri" pitchFamily="34" charset="0"/>
+                <a:ea typeface="Calibri" pitchFamily="34" charset="-122"/>
+                <a:cs typeface="Calibri" pitchFamily="34" charset="-120"/>
+              </a:rPr>
+              <a:t>lateral (xy) median</a:t>
+            </a:r>
+            <a:endParaRPr lang="en-US" sz="1250" dirty="0"/>
+          </a:p>
+          <a:p>
+            <a:pPr algn="ctr" indent="0" marL="0">
+              <a:buNone/>
+            </a:pPr>
+            <a:r>
+              <a:rPr lang="en-US" sz="1250" dirty="0">
+                <a:solidFill>
+                  <a:srgbClr val="836A68"/>
+                </a:solidFill>
+                <a:latin typeface="Calibri" pitchFamily="34" charset="0"/>
+                <a:ea typeface="Calibri" pitchFamily="34" charset="-122"/>
+                <a:cs typeface="Calibri" pitchFamily="34" charset="-120"/>
+              </a:rPr>
+              <a:t>vs 36.5 mm chance</a:t>
+            </a:r>
+            <a:endParaRPr lang="en-US" sz="1250" dirty="0"/>
+          </a:p>
+        </p:txBody>
+      </p:sp>
+      <p:sp>
+        <p:nvSpPr>
+          <p:cNvPr id="7" name="Shape 5"/>
+          <p:cNvSpPr/>
+          <p:nvPr/>
+        </p:nvSpPr>
+        <p:spPr>
+          <a:xfrm>
+            <a:off x="3337560" y="1737360"/>
+            <a:ext cx="2514600" cy="1417320"/>
+          </a:xfrm>
+          <a:prstGeom prst="roundRect">
+            <a:avLst>
+              <a:gd name="adj" fmla="val 5806"/>
+            </a:avLst>
+          </a:prstGeom>
+          <a:solidFill>
+            <a:srgbClr val="FBF4F2"/>
+          </a:solidFill>
+          <a:ln w="12700">
+            <a:solidFill>
+              <a:srgbClr val="E7D6D1"/>
+            </a:solidFill>
+            <a:prstDash val="solid"/>
+          </a:ln>
+          <a:effectLst>
+            <a:outerShdw sx="100000" sy="100000" kx="0" ky="0" algn="bl" rotWithShape="0" blurRad="88900" dist="38100" dir="5400000">
+              <a:srgbClr val="7A5C5E">
+                <a:alpha val="18000"/>
+              </a:srgbClr>
+            </a:outerShdw>
+          </a:effectLst>
+        </p:spPr>
+      </p:sp>
+      <p:sp>
+        <p:nvSpPr>
+          <p:cNvPr id="8" name="Text 6"/>
+          <p:cNvSpPr/>
+          <p:nvPr/>
+        </p:nvSpPr>
+        <p:spPr>
+          <a:xfrm>
+            <a:off x="3337560" y="1901952"/>
+            <a:ext cx="2514600" cy="640080"/>
+          </a:xfrm>
+          <a:prstGeom prst="rect">
+            <a:avLst/>
+          </a:prstGeom>
+          <a:noFill/>
+          <a:ln/>
+        </p:spPr>
+        <p:txBody>
+          <a:bodyPr wrap="square" lIns="0" tIns="0" rIns="0" bIns="0" rtlCol="0" anchor="ctr"/>
+          <a:lstStyle/>
+          <a:p>
+            <a:pPr algn="ctr" indent="0" marL="0">
+              <a:buNone/>
+            </a:pPr>
+            <a:r>
+              <a:rPr lang="en-US" sz="3000" b="1" dirty="0">
+                <a:solidFill>
+                  <a:srgbClr val="C0564A"/>
+                </a:solidFill>
+                <a:latin typeface="Cambria" pitchFamily="34" charset="0"/>
+                <a:ea typeface="Cambria" pitchFamily="34" charset="-122"/>
+                <a:cs typeface="Cambria" pitchFamily="34" charset="-120"/>
+              </a:rPr>
+              <a:t>2.1 mm</a:t>
+            </a:r>
+            <a:endParaRPr lang="en-US" sz="3000" dirty="0"/>
+          </a:p>
+        </p:txBody>
+      </p:sp>
+      <p:sp>
+        <p:nvSpPr>
+          <p:cNvPr id="9" name="Text 7"/>
+          <p:cNvSpPr/>
+          <p:nvPr/>
+        </p:nvSpPr>
+        <p:spPr>
+          <a:xfrm>
+            <a:off x="3429000" y="2606040"/>
+            <a:ext cx="2331720" cy="457200"/>
+          </a:xfrm>
+          <a:prstGeom prst="rect">
+            <a:avLst/>
+          </a:prstGeom>
+          <a:noFill/>
+          <a:ln/>
+        </p:spPr>
+        <p:txBody>
+          <a:bodyPr wrap="square" lIns="0" tIns="0" rIns="0" bIns="0" rtlCol="0" anchor="ctr"/>
+          <a:lstStyle/>
+          <a:p>
+            <a:pPr algn="ctr" indent="0" marL="0">
+              <a:buNone/>
+            </a:pPr>
+            <a:r>
+              <a:rPr lang="en-US" sz="1250" dirty="0">
+                <a:solidFill>
+                  <a:srgbClr val="836A68"/>
+                </a:solidFill>
+                <a:latin typeface="Calibri" pitchFamily="34" charset="0"/>
+                <a:ea typeface="Calibri" pitchFamily="34" charset="-122"/>
+                <a:cs typeface="Calibri" pitchFamily="34" charset="-120"/>
+              </a:rPr>
+              <a:t>depth (z) median</a:t>
+            </a:r>
+            <a:endParaRPr lang="en-US" sz="1250" dirty="0"/>
+          </a:p>
+          <a:p>
+            <a:pPr algn="ctr" indent="0" marL="0">
+              <a:buNone/>
+            </a:pPr>
+            <a:r>
+              <a:rPr lang="en-US" sz="1250" dirty="0">
+                <a:solidFill>
+                  <a:srgbClr val="836A68"/>
+                </a:solidFill>
+                <a:latin typeface="Calibri" pitchFamily="34" charset="0"/>
+                <a:ea typeface="Calibri" pitchFamily="34" charset="-122"/>
+                <a:cs typeface="Calibri" pitchFamily="34" charset="-120"/>
+              </a:rPr>
+              <a:t>vs 16.3 mm chance</a:t>
+            </a:r>
+            <a:endParaRPr lang="en-US" sz="1250" dirty="0"/>
+          </a:p>
+        </p:txBody>
+      </p:sp>
+      <p:sp>
+        <p:nvSpPr>
+          <p:cNvPr id="10" name="Shape 8"/>
+          <p:cNvSpPr/>
+          <p:nvPr/>
+        </p:nvSpPr>
+        <p:spPr>
+          <a:xfrm>
+            <a:off x="6035040" y="1737360"/>
+            <a:ext cx="2514600" cy="1417320"/>
+          </a:xfrm>
+          <a:prstGeom prst="roundRect">
+            <a:avLst>
+              <a:gd name="adj" fmla="val 5806"/>
+            </a:avLst>
+          </a:prstGeom>
+          <a:solidFill>
+            <a:srgbClr val="FBF4F2"/>
+          </a:solidFill>
+          <a:ln w="12700">
+            <a:solidFill>
+              <a:srgbClr val="E7D6D1"/>
+            </a:solidFill>
+            <a:prstDash val="solid"/>
+          </a:ln>
+          <a:effectLst>
+            <a:outerShdw sx="100000" sy="100000" kx="0" ky="0" algn="bl" rotWithShape="0" blurRad="88900" dist="38100" dir="5400000">
+              <a:srgbClr val="7A5C5E">
+                <a:alpha val="18000"/>
+              </a:srgbClr>
+            </a:outerShdw>
+          </a:effectLst>
+        </p:spPr>
+      </p:sp>
+      <p:sp>
+        <p:nvSpPr>
+          <p:cNvPr id="11" name="Text 9"/>
+          <p:cNvSpPr/>
+          <p:nvPr/>
+        </p:nvSpPr>
+        <p:spPr>
+          <a:xfrm>
+            <a:off x="6035040" y="1901952"/>
+            <a:ext cx="2514600" cy="640080"/>
+          </a:xfrm>
+          <a:prstGeom prst="rect">
+            <a:avLst/>
+          </a:prstGeom>
+          <a:noFill/>
+          <a:ln/>
+        </p:spPr>
+        <p:txBody>
+          <a:bodyPr wrap="square" lIns="0" tIns="0" rIns="0" bIns="0" rtlCol="0" anchor="ctr"/>
+          <a:lstStyle/>
+          <a:p>
+            <a:pPr algn="ctr" indent="0" marL="0">
+              <a:buNone/>
+            </a:pPr>
+            <a:r>
+              <a:rPr lang="en-US" sz="3000" b="1" dirty="0">
+                <a:solidFill>
+                  <a:srgbClr val="8E1010"/>
+                </a:solidFill>
+                <a:latin typeface="Cambria" pitchFamily="34" charset="0"/>
+                <a:ea typeface="Cambria" pitchFamily="34" charset="-122"/>
+                <a:cs typeface="Cambria" pitchFamily="34" charset="-120"/>
+              </a:rPr>
+              <a:t>93 %</a:t>
+            </a:r>
+            <a:endParaRPr lang="en-US" sz="3000" dirty="0"/>
+          </a:p>
+        </p:txBody>
+      </p:sp>
+      <p:sp>
+        <p:nvSpPr>
+          <p:cNvPr id="12" name="Text 10"/>
+          <p:cNvSpPr/>
+          <p:nvPr/>
+        </p:nvSpPr>
+        <p:spPr>
+          <a:xfrm>
+            <a:off x="6126480" y="2606040"/>
+            <a:ext cx="2331720" cy="457200"/>
+          </a:xfrm>
+          <a:prstGeom prst="rect">
+            <a:avLst/>
+          </a:prstGeom>
+          <a:noFill/>
+          <a:ln/>
+        </p:spPr>
+        <p:txBody>
+          <a:bodyPr wrap="square" lIns="0" tIns="0" rIns="0" bIns="0" rtlCol="0" anchor="ctr"/>
+          <a:lstStyle/>
+          <a:p>
+            <a:pPr algn="ctr" indent="0" marL="0">
+              <a:buNone/>
+            </a:pPr>
+            <a:r>
+              <a:rPr lang="en-US" sz="1250" dirty="0">
+                <a:solidFill>
+                  <a:srgbClr val="836A68"/>
+                </a:solidFill>
+                <a:latin typeface="Calibri" pitchFamily="34" charset="0"/>
+                <a:ea typeface="Calibri" pitchFamily="34" charset="-122"/>
+                <a:cs typeface="Calibri" pitchFamily="34" charset="-120"/>
+              </a:rPr>
+              <a:t>of positions within</a:t>
+            </a:r>
+            <a:endParaRPr lang="en-US" sz="1250" dirty="0"/>
+          </a:p>
+          <a:p>
+            <a:pPr algn="ctr" indent="0" marL="0">
+              <a:buNone/>
+            </a:pPr>
+            <a:r>
+              <a:rPr lang="en-US" sz="1250" dirty="0">
+                <a:solidFill>
+                  <a:srgbClr val="836A68"/>
+                </a:solidFill>
+                <a:latin typeface="Calibri" pitchFamily="34" charset="0"/>
+                <a:ea typeface="Calibri" pitchFamily="34" charset="-122"/>
+                <a:cs typeface="Calibri" pitchFamily="34" charset="-120"/>
+              </a:rPr>
+              <a:t>10 mm laterally</a:t>
+            </a:r>
+            <a:endParaRPr lang="en-US" sz="1250" dirty="0"/>
+          </a:p>
+        </p:txBody>
+      </p:sp>
+      <p:sp>
+        <p:nvSpPr>
+          <p:cNvPr id="13" name="Shape 11"/>
+          <p:cNvSpPr/>
+          <p:nvPr/>
+        </p:nvSpPr>
+        <p:spPr>
+          <a:xfrm>
+            <a:off x="8732520" y="1737360"/>
+            <a:ext cx="2514600" cy="1417320"/>
+          </a:xfrm>
+          <a:prstGeom prst="roundRect">
+            <a:avLst>
+              <a:gd name="adj" fmla="val 5806"/>
+            </a:avLst>
+          </a:prstGeom>
+          <a:solidFill>
+            <a:srgbClr val="FBF4F2"/>
+          </a:solidFill>
+          <a:ln w="12700">
+            <a:solidFill>
+              <a:srgbClr val="E7D6D1"/>
+            </a:solidFill>
+            <a:prstDash val="solid"/>
+          </a:ln>
+          <a:effectLst>
+            <a:outerShdw sx="100000" sy="100000" kx="0" ky="0" algn="bl" rotWithShape="0" blurRad="88900" dist="38100" dir="5400000">
+              <a:srgbClr val="7A5C5E">
+                <a:alpha val="18000"/>
+              </a:srgbClr>
+            </a:outerShdw>
+          </a:effectLst>
+        </p:spPr>
+      </p:sp>
+      <p:sp>
+        <p:nvSpPr>
+          <p:cNvPr id="14" name="Text 12"/>
+          <p:cNvSpPr/>
+          <p:nvPr/>
+        </p:nvSpPr>
+        <p:spPr>
+          <a:xfrm>
+            <a:off x="8732520" y="1901952"/>
+            <a:ext cx="2514600" cy="640080"/>
+          </a:xfrm>
+          <a:prstGeom prst="rect">
+            <a:avLst/>
+          </a:prstGeom>
+          <a:noFill/>
+          <a:ln/>
+        </p:spPr>
+        <p:txBody>
+          <a:bodyPr wrap="square" lIns="0" tIns="0" rIns="0" bIns="0" rtlCol="0" anchor="ctr"/>
+          <a:lstStyle/>
+          <a:p>
+            <a:pPr algn="ctr" indent="0" marL="0">
+              <a:buNone/>
+            </a:pPr>
+            <a:r>
+              <a:rPr lang="en-US" sz="3000" b="1" dirty="0">
+                <a:solidFill>
+                  <a:srgbClr val="C8890B"/>
+                </a:solidFill>
+                <a:latin typeface="Cambria" pitchFamily="34" charset="0"/>
+                <a:ea typeface="Cambria" pitchFamily="34" charset="-122"/>
+                <a:cs typeface="Cambria" pitchFamily="34" charset="-120"/>
+              </a:rPr>
+              <a:t>3.6 / 2.1</a:t>
+            </a:r>
+            <a:endParaRPr lang="en-US" sz="3000" dirty="0"/>
+          </a:p>
+        </p:txBody>
+      </p:sp>
+      <p:sp>
+        <p:nvSpPr>
+          <p:cNvPr id="15" name="Text 13"/>
+          <p:cNvSpPr/>
+          <p:nvPr/>
+        </p:nvSpPr>
+        <p:spPr>
+          <a:xfrm>
+            <a:off x="8823960" y="2606040"/>
+            <a:ext cx="2331720" cy="457200"/>
+          </a:xfrm>
+          <a:prstGeom prst="rect">
+            <a:avLst/>
+          </a:prstGeom>
+          <a:noFill/>
+          <a:ln/>
+        </p:spPr>
+        <p:txBody>
+          <a:bodyPr wrap="square" lIns="0" tIns="0" rIns="0" bIns="0" rtlCol="0" anchor="ctr"/>
+          <a:lstStyle/>
+          <a:p>
+            <a:pPr algn="ctr" indent="0" marL="0">
+              <a:buNone/>
+            </a:pPr>
+            <a:r>
+              <a:rPr lang="en-US" sz="1250" dirty="0">
+                <a:solidFill>
+                  <a:srgbClr val="836A68"/>
+                </a:solidFill>
+                <a:latin typeface="Calibri" pitchFamily="34" charset="0"/>
+                <a:ea typeface="Calibri" pitchFamily="34" charset="-122"/>
+                <a:cs typeface="Calibri" pitchFamily="34" charset="-120"/>
+              </a:rPr>
+              <a:t>beet (dielectric)</a:t>
+            </a:r>
+            <a:endParaRPr lang="en-US" sz="1250" dirty="0"/>
+          </a:p>
+          <a:p>
+            <a:pPr algn="ctr" indent="0" marL="0">
+              <a:buNone/>
+            </a:pPr>
+            <a:r>
+              <a:rPr lang="en-US" sz="1250" dirty="0">
+                <a:solidFill>
+                  <a:srgbClr val="836A68"/>
+                </a:solidFill>
+                <a:latin typeface="Calibri" pitchFamily="34" charset="0"/>
+                <a:ea typeface="Calibri" pitchFamily="34" charset="-122"/>
+                <a:cs typeface="Calibri" pitchFamily="34" charset="-120"/>
+              </a:rPr>
+              <a:t>xy / z, same as metal</a:t>
+            </a:r>
+            <a:endParaRPr lang="en-US" sz="1250" dirty="0"/>
+          </a:p>
+        </p:txBody>
+      </p:sp>
+      <p:sp>
+        <p:nvSpPr>
+          <p:cNvPr id="16" name="Shape 14"/>
+          <p:cNvSpPr/>
+          <p:nvPr/>
+        </p:nvSpPr>
+        <p:spPr>
+          <a:xfrm>
+            <a:off x="640080" y="3429000"/>
+            <a:ext cx="10607040" cy="2697480"/>
+          </a:xfrm>
+          <a:prstGeom prst="roundRect">
+            <a:avLst>
+              <a:gd name="adj" fmla="val 3051"/>
+            </a:avLst>
+          </a:prstGeom>
+          <a:solidFill>
+            <a:srgbClr val="FBF4F2"/>
+          </a:solidFill>
+          <a:ln w="12700">
+            <a:solidFill>
+              <a:srgbClr val="E7D6D1"/>
+            </a:solidFill>
+            <a:prstDash val="solid"/>
+          </a:ln>
+          <a:effectLst>
+            <a:outerShdw sx="100000" sy="100000" kx="0" ky="0" algn="bl" rotWithShape="0" blurRad="88900" dist="38100" dir="5400000">
+              <a:srgbClr val="7A5C5E">
+                <a:alpha val="18000"/>
+              </a:srgbClr>
+            </a:outerShdw>
+          </a:effectLst>
+        </p:spPr>
+      </p:sp>
+      <p:sp>
+        <p:nvSpPr>
+          <p:cNvPr id="17" name="Text 15"/>
+          <p:cNvSpPr/>
+          <p:nvPr/>
+        </p:nvSpPr>
+        <p:spPr>
+          <a:xfrm>
+            <a:off x="914400" y="3611880"/>
+            <a:ext cx="9144000" cy="365760"/>
+          </a:xfrm>
+          <a:prstGeom prst="rect">
+            <a:avLst/>
+          </a:prstGeom>
+          <a:noFill/>
+          <a:ln/>
+        </p:spPr>
+        <p:txBody>
+          <a:bodyPr wrap="square" lIns="0" tIns="0" rIns="0" bIns="0" rtlCol="0" anchor="ctr"/>
+          <a:lstStyle/>
+          <a:p>
+            <a:pPr indent="0" marL="0">
+              <a:buNone/>
+            </a:pPr>
+            <a:r>
+              <a:rPr lang="en-US" sz="1700" b="1" dirty="0">
+                <a:solidFill>
+                  <a:srgbClr val="BE0000"/>
+                </a:solidFill>
+                <a:latin typeface="Cambria" pitchFamily="34" charset="0"/>
+                <a:ea typeface="Cambria" pitchFamily="34" charset="-122"/>
+                <a:cs typeface="Cambria" pitchFamily="34" charset="-120"/>
+              </a:rPr>
+              <a:t>What this establishes</a:t>
+            </a:r>
+            <a:endParaRPr lang="en-US" sz="1700" dirty="0"/>
+          </a:p>
+        </p:txBody>
+      </p:sp>
+      <p:sp>
+        <p:nvSpPr>
+          <p:cNvPr id="18" name="Text 16"/>
+          <p:cNvSpPr/>
+          <p:nvPr/>
+        </p:nvSpPr>
+        <p:spPr>
+          <a:xfrm>
+            <a:off x="914400" y="4114800"/>
+            <a:ext cx="10332720" cy="1920240"/>
           </a:xfrm>
           <a:prstGeom prst="rect">
             <a:avLst/>
@@ -6355,7 +6905,7 @@
               <a:buChar char="•"/>
             </a:pPr>
             <a:r>
-              <a:rPr lang="en-US" sz="1150" dirty="0">
+              <a:rPr lang="en-US" sz="1350" dirty="0">
                 <a:solidFill>
                   <a:srgbClr val="2A1618"/>
                 </a:solidFill>
@@ -6363,9 +6913,9 @@
                 <a:ea typeface="Calibri" pitchFamily="34" charset="-122"/>
                 <a:cs typeface="Calibri" pitchFamily="34" charset="-120"/>
               </a:rPr>
-              <a:t>Interior unseen depths: ~1 to 3 mm, a continuous learned depth map.</a:t>
-            </a:r>
-            <a:endParaRPr lang="en-US" sz="1150" dirty="0"/>
+              <a:t>Depth is NOT the weak axis. With fine depth sampling and full-band frequency, z resolves to ~2 mm, better than the lateral k-NN floor.</a:t>
+            </a:r>
+            <a:endParaRPr lang="en-US" sz="1350" dirty="0"/>
           </a:p>
           <a:p>
             <a:pPr marL="342900" indent="-342900">
@@ -6376,7 +6926,7 @@
               <a:buChar char="•"/>
             </a:pPr>
             <a:r>
-              <a:rPr lang="en-US" sz="1150" dirty="0">
+              <a:rPr lang="en-US" sz="1350" dirty="0">
                 <a:solidFill>
                   <a:srgbClr val="2A1618"/>
                 </a:solidFill>
@@ -6384,9 +6934,9 @@
                 <a:ea typeface="Calibri" pitchFamily="34" charset="-122"/>
                 <a:cs typeface="Calibri" pitchFamily="34" charset="-120"/>
               </a:rPr>
-              <a:t>Only the two outer edge depths (-15 / +45) blow up, pure extrapolation.</a:t>
-            </a:r>
-            <a:endParaRPr lang="en-US" sz="1150" dirty="0"/>
+              <a:t>A dielectric (beet) tumor localizes identically to metal (3.6 / 2.1 mm). In the noiseless sim the ~19 percent weaker contrast costs nothing.</a:t>
+            </a:r>
+            <a:endParaRPr lang="en-US" sz="1350" dirty="0"/>
           </a:p>
           <a:p>
             <a:pPr marL="342900" indent="-342900">
@@ -6397,7 +6947,7 @@
               <a:buChar char="•"/>
             </a:pPr>
             <a:r>
-              <a:rPr lang="en-US" sz="1150" dirty="0">
+              <a:rPr lang="en-US" sz="1350" dirty="0">
                 <a:solidFill>
                   <a:srgbClr val="2A1618"/>
                 </a:solidFill>
@@ -6405,46 +6955,7 @@
                 <a:ea typeface="Calibri" pitchFamily="34" charset="-122"/>
                 <a:cs typeface="Calibri" pitchFamily="34" charset="-120"/>
               </a:rPr>
-              <a:t>Extending the sweep turned the OLD outer edges into good interior points.</a:t>
-            </a:r>
-            <a:endParaRPr lang="en-US" sz="1150" dirty="0"/>
-          </a:p>
-        </p:txBody>
-      </p:sp>
-      <p:sp>
-        <p:nvSpPr>
-          <p:cNvPr id="8" name="Text 5"/>
-          <p:cNvSpPr/>
-          <p:nvPr/>
-        </p:nvSpPr>
-        <p:spPr>
-          <a:xfrm>
-            <a:off x="548640" y="6172200"/>
-            <a:ext cx="11091672" cy="457200"/>
-          </a:xfrm>
-          <a:prstGeom prst="rect">
-            <a:avLst/>
-          </a:prstGeom>
-          <a:noFill/>
-          <a:ln/>
-        </p:spPr>
-        <p:txBody>
-          <a:bodyPr wrap="square" lIns="0" tIns="0" rIns="0" bIns="0" rtlCol="0" anchor="ctr"/>
-          <a:lstStyle/>
-          <a:p>
-            <a:pPr algn="ctr" indent="0" marL="0">
-              <a:buNone/>
-            </a:pPr>
-            <a:r>
-              <a:rPr lang="en-US" sz="1350" i="1" dirty="0">
-                <a:solidFill>
-                  <a:srgbClr val="836A68"/>
-                </a:solidFill>
-                <a:latin typeface="Calibri" pitchFamily="34" charset="0"/>
-                <a:ea typeface="Calibri" pitchFamily="34" charset="-122"/>
-                <a:cs typeface="Calibri" pitchFamily="34" charset="-120"/>
-              </a:rPr>
-              <a:t>Usable depth is bounded by the sampling range, not the model. Sample wider and the good region grows.</a:t>
+              <a:t>Chance is 36 mm laterally / 16 mm in depth, so the model is about 10x better than guessing the centre on both axes.</a:t>
             </a:r>
             <a:endParaRPr lang="en-US" sz="1350" dirty="0"/>
           </a:p>
@@ -6515,7 +7026,7 @@
                 <a:ea typeface="Cambria" pitchFamily="34" charset="-122"/>
                 <a:cs typeface="Cambria" pitchFamily="34" charset="-120"/>
               </a:rPr>
-              <a:t>Predicted vs. actual, by depth</a:t>
+              <a:t>Predicting an unseen depth plane</a:t>
             </a:r>
             <a:endParaRPr lang="en-US" sz="2900" dirty="0"/>
           </a:p>
@@ -6554,26 +7065,50 @@
                 <a:ea typeface="Calibri" pitchFamily="34" charset="-122"/>
                 <a:cs typeface="Calibri" pitchFamily="34" charset="-120"/>
               </a:rPr>
-              <a:t>Arrows = lateral error, marker color = depth error, red ring = grid-edge position</a:t>
+              <a:t>Leave one whole depth out; interior depths interpolate, only the outer edge depths fail</a:t>
             </a:r>
             <a:endParaRPr lang="en-US" sz="1400" dirty="0"/>
           </a:p>
         </p:txBody>
       </p:sp>
-      <p:sp>
-        <p:nvSpPr>
-          <p:cNvPr id="4" name="Shape 2"/>
-          <p:cNvSpPr/>
-          <p:nvPr/>
-        </p:nvSpPr>
-        <p:spPr>
-          <a:xfrm>
-            <a:off x="310896" y="1581912"/>
-            <a:ext cx="3794760" cy="3977640"/>
+      <p:pic>
+        <p:nvPicPr>
+          <p:cNvPr id="4" name="Image 0" descr="sim_depth_lopo.png">    </p:cNvPr>
+          <p:cNvPicPr>
+            <a:picLocks noChangeAspect="1"/>
+          </p:cNvPicPr>
+          <p:nvPr/>
+        </p:nvPicPr>
+        <p:blipFill>
+          <a:blip r:embed="rId1"/>
+          <a:stretch>
+            <a:fillRect/>
+          </a:stretch>
+        </p:blipFill>
+        <p:spPr>
+          <a:xfrm>
+            <a:off x="365760" y="1600200"/>
+            <a:ext cx="8595360" cy="3566160"/>
+          </a:xfrm>
+          <a:prstGeom prst="rect">
+            <a:avLst/>
+          </a:prstGeom>
+        </p:spPr>
+      </p:pic>
+      <p:sp>
+        <p:nvSpPr>
+          <p:cNvPr id="5" name="Shape 2"/>
+          <p:cNvSpPr/>
+          <p:nvPr/>
+        </p:nvSpPr>
+        <p:spPr>
+          <a:xfrm>
+            <a:off x="9098280" y="1600200"/>
+            <a:ext cx="2651760" cy="3566160"/>
           </a:xfrm>
           <a:prstGeom prst="roundRect">
             <a:avLst>
-              <a:gd name="adj" fmla="val 2169"/>
+              <a:gd name="adj" fmla="val 3103"/>
             </a:avLst>
           </a:prstGeom>
           <a:solidFill>
@@ -6594,30 +7129,6 @@
           </a:effectLst>
         </p:spPr>
       </p:sp>
-      <p:pic>
-        <p:nvPicPr>
-          <p:cNvPr id="5" name="Image 0" descr="sim_depth_examples/sim_depthplot_zp15_n25.png">    </p:cNvPr>
-          <p:cNvPicPr>
-            <a:picLocks noChangeAspect="1"/>
-          </p:cNvPicPr>
-          <p:nvPr/>
-        </p:nvPicPr>
-        <p:blipFill>
-          <a:blip r:embed="rId1"/>
-          <a:stretch>
-            <a:fillRect/>
-          </a:stretch>
-        </p:blipFill>
-        <p:spPr>
-          <a:xfrm>
-            <a:off x="402336" y="1691640"/>
-            <a:ext cx="3611880" cy="3429000"/>
-          </a:xfrm>
-          <a:prstGeom prst="rect">
-            <a:avLst/>
-          </a:prstGeom>
-        </p:spPr>
-      </p:pic>
       <p:sp>
         <p:nvSpPr>
           <p:cNvPr id="6" name="Text 3"/>
@@ -6626,240 +7137,131 @@
         </p:nvSpPr>
         <p:spPr>
           <a:xfrm>
-            <a:off x="310896" y="5120640"/>
-            <a:ext cx="3794760" cy="329184"/>
-          </a:xfrm>
-          <a:prstGeom prst="rect">
-            <a:avLst/>
-          </a:prstGeom>
-          <a:noFill/>
-          <a:ln/>
-        </p:spPr>
-        <p:txBody>
-          <a:bodyPr wrap="square" lIns="0" tIns="0" rIns="0" bIns="0" rtlCol="0" anchor="ctr"/>
-          <a:lstStyle/>
-          <a:p>
-            <a:pPr algn="ctr" indent="0" marL="0">
-              <a:buNone/>
-            </a:pPr>
-            <a:r>
-              <a:rPr lang="en-US" sz="1300" b="1" dirty="0">
+            <a:off x="9281160" y="1737360"/>
+            <a:ext cx="2377440" cy="548640"/>
+          </a:xfrm>
+          <a:prstGeom prst="rect">
+            <a:avLst/>
+          </a:prstGeom>
+          <a:noFill/>
+          <a:ln/>
+        </p:spPr>
+        <p:txBody>
+          <a:bodyPr wrap="square" lIns="0" tIns="0" rIns="0" bIns="0" rtlCol="0" anchor="ctr"/>
+          <a:lstStyle/>
+          <a:p>
+            <a:pPr indent="0" marL="0">
+              <a:buNone/>
+            </a:pPr>
+            <a:r>
+              <a:rPr lang="en-US" sz="1400" b="1" dirty="0">
                 <a:solidFill>
                   <a:srgbClr val="BE0000"/>
+                </a:solidFill>
+                <a:latin typeface="Cambria" pitchFamily="34" charset="0"/>
+                <a:ea typeface="Cambria" pitchFamily="34" charset="-122"/>
+                <a:cs typeface="Cambria" pitchFamily="34" charset="-120"/>
+              </a:rPr>
+              <a:t>Range-bound, not model-bound</a:t>
+            </a:r>
+            <a:endParaRPr lang="en-US" sz="1400" dirty="0"/>
+          </a:p>
+        </p:txBody>
+      </p:sp>
+      <p:sp>
+        <p:nvSpPr>
+          <p:cNvPr id="7" name="Text 4"/>
+          <p:cNvSpPr/>
+          <p:nvPr/>
+        </p:nvSpPr>
+        <p:spPr>
+          <a:xfrm>
+            <a:off x="9281160" y="2377440"/>
+            <a:ext cx="2377440" cy="2743200"/>
+          </a:xfrm>
+          <a:prstGeom prst="rect">
+            <a:avLst/>
+          </a:prstGeom>
+          <a:noFill/>
+          <a:ln/>
+        </p:spPr>
+        <p:txBody>
+          <a:bodyPr wrap="square" lIns="0" tIns="0" rIns="0" bIns="0" rtlCol="0" anchor="t"/>
+          <a:lstStyle/>
+          <a:p>
+            <a:pPr marL="342900" indent="-342900">
+              <a:spcAft>
+                <a:spcPts val="800"/>
+              </a:spcAft>
+              <a:buSzPct val="100000"/>
+              <a:buChar char="•"/>
+            </a:pPr>
+            <a:r>
+              <a:rPr lang="en-US" sz="1150" dirty="0">
+                <a:solidFill>
+                  <a:srgbClr val="2A1618"/>
                 </a:solidFill>
                 <a:latin typeface="Calibri" pitchFamily="34" charset="0"/>
                 <a:ea typeface="Calibri" pitchFamily="34" charset="-122"/>
                 <a:cs typeface="Calibri" pitchFamily="34" charset="-120"/>
               </a:rPr>
-              <a:t>z = +15 mm  (peak signal)</a:t>
-            </a:r>
-            <a:endParaRPr lang="en-US" sz="1300" dirty="0"/>
-          </a:p>
-        </p:txBody>
-      </p:sp>
-      <p:sp>
-        <p:nvSpPr>
-          <p:cNvPr id="7" name="Shape 4"/>
-          <p:cNvSpPr/>
-          <p:nvPr/>
-        </p:nvSpPr>
-        <p:spPr>
-          <a:xfrm>
-            <a:off x="4197096" y="1581912"/>
-            <a:ext cx="3794760" cy="3977640"/>
-          </a:xfrm>
-          <a:prstGeom prst="roundRect">
-            <a:avLst>
-              <a:gd name="adj" fmla="val 2169"/>
-            </a:avLst>
-          </a:prstGeom>
-          <a:solidFill>
-            <a:srgbClr val="FBF4F2"/>
-          </a:solidFill>
-          <a:ln w="12700">
-            <a:solidFill>
-              <a:srgbClr val="E7D6D1"/>
-            </a:solidFill>
-            <a:prstDash val="solid"/>
-          </a:ln>
-          <a:effectLst>
-            <a:outerShdw sx="100000" sy="100000" kx="0" ky="0" algn="bl" rotWithShape="0" blurRad="88900" dist="38100" dir="5400000">
-              <a:srgbClr val="7A5C5E">
-                <a:alpha val="18000"/>
-              </a:srgbClr>
-            </a:outerShdw>
-          </a:effectLst>
-        </p:spPr>
-      </p:sp>
-      <p:pic>
-        <p:nvPicPr>
-          <p:cNvPr id="8" name="Image 1" descr="sim_depth_examples/sim_depthplot_zp30_n25.png">    </p:cNvPr>
-          <p:cNvPicPr>
-            <a:picLocks noChangeAspect="1"/>
-          </p:cNvPicPr>
-          <p:nvPr/>
-        </p:nvPicPr>
-        <p:blipFill>
-          <a:blip r:embed="rId2"/>
-          <a:stretch>
-            <a:fillRect/>
-          </a:stretch>
-        </p:blipFill>
-        <p:spPr>
-          <a:xfrm>
-            <a:off x="4288536" y="1691640"/>
-            <a:ext cx="3611880" cy="3429000"/>
-          </a:xfrm>
-          <a:prstGeom prst="rect">
-            <a:avLst/>
-          </a:prstGeom>
-        </p:spPr>
-      </p:pic>
-      <p:sp>
-        <p:nvSpPr>
-          <p:cNvPr id="9" name="Text 5"/>
-          <p:cNvSpPr/>
-          <p:nvPr/>
-        </p:nvSpPr>
-        <p:spPr>
-          <a:xfrm>
-            <a:off x="4197096" y="5120640"/>
-            <a:ext cx="3794760" cy="329184"/>
-          </a:xfrm>
-          <a:prstGeom prst="rect">
-            <a:avLst/>
-          </a:prstGeom>
-          <a:noFill/>
-          <a:ln/>
-        </p:spPr>
-        <p:txBody>
-          <a:bodyPr wrap="square" lIns="0" tIns="0" rIns="0" bIns="0" rtlCol="0" anchor="ctr"/>
-          <a:lstStyle/>
-          <a:p>
-            <a:pPr algn="ctr" indent="0" marL="0">
-              <a:buNone/>
-            </a:pPr>
-            <a:r>
-              <a:rPr lang="en-US" sz="1300" b="1" dirty="0">
-                <a:solidFill>
-                  <a:srgbClr val="BE0000"/>
+              <a:t>Interior unseen depths: ~1 to 3 mm, a continuous learned depth map.</a:t>
+            </a:r>
+            <a:endParaRPr lang="en-US" sz="1150" dirty="0"/>
+          </a:p>
+          <a:p>
+            <a:pPr marL="342900" indent="-342900">
+              <a:spcAft>
+                <a:spcPts val="800"/>
+              </a:spcAft>
+              <a:buSzPct val="100000"/>
+              <a:buChar char="•"/>
+            </a:pPr>
+            <a:r>
+              <a:rPr lang="en-US" sz="1150" dirty="0">
+                <a:solidFill>
+                  <a:srgbClr val="2A1618"/>
                 </a:solidFill>
                 <a:latin typeface="Calibri" pitchFamily="34" charset="0"/>
                 <a:ea typeface="Calibri" pitchFamily="34" charset="-122"/>
                 <a:cs typeface="Calibri" pitchFamily="34" charset="-120"/>
               </a:rPr>
-              <a:t>z = +30 mm  (interior)</a:t>
-            </a:r>
-            <a:endParaRPr lang="en-US" sz="1300" dirty="0"/>
-          </a:p>
-        </p:txBody>
-      </p:sp>
-      <p:sp>
-        <p:nvSpPr>
-          <p:cNvPr id="10" name="Shape 6"/>
-          <p:cNvSpPr/>
-          <p:nvPr/>
-        </p:nvSpPr>
-        <p:spPr>
-          <a:xfrm>
-            <a:off x="8083296" y="1581912"/>
-            <a:ext cx="3794760" cy="3977640"/>
-          </a:xfrm>
-          <a:prstGeom prst="roundRect">
-            <a:avLst>
-              <a:gd name="adj" fmla="val 2169"/>
-            </a:avLst>
-          </a:prstGeom>
-          <a:solidFill>
-            <a:srgbClr val="FBF4F2"/>
-          </a:solidFill>
-          <a:ln w="12700">
-            <a:solidFill>
-              <a:srgbClr val="E7D6D1"/>
-            </a:solidFill>
-            <a:prstDash val="solid"/>
-          </a:ln>
-          <a:effectLst>
-            <a:outerShdw sx="100000" sy="100000" kx="0" ky="0" algn="bl" rotWithShape="0" blurRad="88900" dist="38100" dir="5400000">
-              <a:srgbClr val="7A5C5E">
-                <a:alpha val="18000"/>
-              </a:srgbClr>
-            </a:outerShdw>
-          </a:effectLst>
-        </p:spPr>
-      </p:sp>
-      <p:pic>
-        <p:nvPicPr>
-          <p:cNvPr id="11" name="Image 2" descr="sim_depth_examples/sim_depthplot_zp45_n25.png">    </p:cNvPr>
-          <p:cNvPicPr>
-            <a:picLocks noChangeAspect="1"/>
-          </p:cNvPicPr>
-          <p:nvPr/>
-        </p:nvPicPr>
-        <p:blipFill>
-          <a:blip r:embed="rId3"/>
-          <a:stretch>
-            <a:fillRect/>
-          </a:stretch>
-        </p:blipFill>
-        <p:spPr>
-          <a:xfrm>
-            <a:off x="8174736" y="1691640"/>
-            <a:ext cx="3611880" cy="3429000"/>
-          </a:xfrm>
-          <a:prstGeom prst="rect">
-            <a:avLst/>
-          </a:prstGeom>
-        </p:spPr>
-      </p:pic>
-      <p:sp>
-        <p:nvSpPr>
-          <p:cNvPr id="12" name="Text 7"/>
-          <p:cNvSpPr/>
-          <p:nvPr/>
-        </p:nvSpPr>
-        <p:spPr>
-          <a:xfrm>
-            <a:off x="8083296" y="5120640"/>
-            <a:ext cx="3794760" cy="329184"/>
-          </a:xfrm>
-          <a:prstGeom prst="rect">
-            <a:avLst/>
-          </a:prstGeom>
-          <a:noFill/>
-          <a:ln/>
-        </p:spPr>
-        <p:txBody>
-          <a:bodyPr wrap="square" lIns="0" tIns="0" rIns="0" bIns="0" rtlCol="0" anchor="ctr"/>
-          <a:lstStyle/>
-          <a:p>
-            <a:pPr algn="ctr" indent="0" marL="0">
-              <a:buNone/>
-            </a:pPr>
-            <a:r>
-              <a:rPr lang="en-US" sz="1300" b="1" dirty="0">
-                <a:solidFill>
-                  <a:srgbClr val="BE0000"/>
+              <a:t>Only the two outer edge depths (-15 / +45) blow up, pure extrapolation.</a:t>
+            </a:r>
+            <a:endParaRPr lang="en-US" sz="1150" dirty="0"/>
+          </a:p>
+          <a:p>
+            <a:pPr marL="342900" indent="-342900">
+              <a:spcAft>
+                <a:spcPts val="800"/>
+              </a:spcAft>
+              <a:buSzPct val="100000"/>
+              <a:buChar char="•"/>
+            </a:pPr>
+            <a:r>
+              <a:rPr lang="en-US" sz="1150" dirty="0">
+                <a:solidFill>
+                  <a:srgbClr val="2A1618"/>
                 </a:solidFill>
                 <a:latin typeface="Calibri" pitchFamily="34" charset="0"/>
                 <a:ea typeface="Calibri" pitchFamily="34" charset="-122"/>
                 <a:cs typeface="Calibri" pitchFamily="34" charset="-120"/>
               </a:rPr>
-              <a:t>z = +45 mm  (outer edge)</a:t>
-            </a:r>
-            <a:endParaRPr lang="en-US" sz="1300" dirty="0"/>
-          </a:p>
-        </p:txBody>
-      </p:sp>
-      <p:sp>
-        <p:nvSpPr>
-          <p:cNvPr id="13" name="Text 8"/>
-          <p:cNvSpPr/>
-          <p:nvPr/>
-        </p:nvSpPr>
-        <p:spPr>
-          <a:xfrm>
-            <a:off x="548640" y="6126480"/>
+              <a:t>Extending the sweep turned the OLD outer edges into good interior points.</a:t>
+            </a:r>
+            <a:endParaRPr lang="en-US" sz="1150" dirty="0"/>
+          </a:p>
+        </p:txBody>
+      </p:sp>
+      <p:sp>
+        <p:nvSpPr>
+          <p:cNvPr id="8" name="Text 5"/>
+          <p:cNvSpPr/>
+          <p:nvPr/>
+        </p:nvSpPr>
+        <p:spPr>
+          <a:xfrm>
+            <a:off x="548640" y="6172200"/>
             <a:ext cx="11091672" cy="457200"/>
           </a:xfrm>
           <a:prstGeom prst="rect">
@@ -6876,7 +7278,7 @@
               <a:buNone/>
             </a:pPr>
             <a:r>
-              <a:rPr lang="en-US" sz="1300" i="1" dirty="0">
+              <a:rPr lang="en-US" sz="1350" i="1" dirty="0">
                 <a:solidFill>
                   <a:srgbClr val="836A68"/>
                 </a:solidFill>
@@ -6884,9 +7286,9 @@
                 <a:ea typeface="Calibri" pitchFamily="34" charset="-122"/>
                 <a:cs typeface="Calibri" pitchFamily="34" charset="-120"/>
               </a:rPr>
-              <a:t>Interior depths (z=+15/+30) predict tightly; the +45 mm outer edge shows the extrapolation blow-up in both lateral arrows and depth color.</a:t>
-            </a:r>
-            <a:endParaRPr lang="en-US" sz="1300" dirty="0"/>
+              <a:t>Usable depth is bounded by the sampling range, not the model. Sample wider and the good region grows.</a:t>
+            </a:r>
+            <a:endParaRPr lang="en-US" sz="1350" dirty="0"/>
           </a:p>
         </p:txBody>
       </p:sp>

</xml_diff>

<commit_message>
Wire real setup photos into decks
- Deck 1: "three phantoms in pictures" slide uses A3/A3F4/A3F5 photos
- Deck 2: sim setup slide uses SimulatedImage01/02 HFSS screenshots
- Deck 3: new "two setups side by side" slide (A3 photo + HFSS model)
Removed unused placeholder images.

Co-Authored-By: Claude Opus 4.8 <noreply@anthropic.com>
</commit_message>
<xml_diff>
--- a/regression_deck/Deck2_Simulated_Regression.pptx
+++ b/regression_deck/Deck2_Simulated_Regression.pptx
@@ -4184,7 +4184,7 @@
                 <a:ea typeface="Calibri" pitchFamily="34" charset="-122"/>
                 <a:cs typeface="Calibri" pitchFamily="34" charset="-120"/>
               </a:rPr>
-              <a:t>HFSS model of the antenna array, phantom and tumor</a:t>
+              <a:t>HFSS model of the phantom, oil, antennas and tumor</a:t>
             </a:r>
             <a:endParaRPr lang="en-US" sz="1400" dirty="0"/>
           </a:p>
@@ -4198,12 +4198,12 @@
         </p:nvSpPr>
         <p:spPr>
           <a:xfrm>
-            <a:off x="960120" y="1645920"/>
-            <a:ext cx="4937760" cy="4069080"/>
+            <a:off x="1143000" y="1691640"/>
+            <a:ext cx="4892040" cy="4526280"/>
           </a:xfrm>
           <a:prstGeom prst="roundRect">
             <a:avLst>
-              <a:gd name="adj" fmla="val 2022"/>
+              <a:gd name="adj" fmla="val 1818"/>
             </a:avLst>
           </a:prstGeom>
           <a:solidFill>
@@ -4226,7 +4226,7 @@
       </p:sp>
       <p:pic>
         <p:nvPicPr>
-          <p:cNvPr id="5" name="Image 0" descr="setup_photos/sim_model.png">    </p:cNvPr>
+          <p:cNvPr id="5" name="Image 0" descr="setup_photos/SimulatedImage01.png">    </p:cNvPr>
           <p:cNvPicPr>
             <a:picLocks noChangeAspect="1"/>
           </p:cNvPicPr>
@@ -4240,8 +4240,8 @@
         </p:blipFill>
         <p:spPr>
           <a:xfrm>
-            <a:off x="1051560" y="1737360"/>
-            <a:ext cx="4754880" cy="3566160"/>
+            <a:off x="1234440" y="1783080"/>
+            <a:ext cx="4709160" cy="4023360"/>
           </a:xfrm>
           <a:prstGeom prst="rect">
             <a:avLst/>
@@ -4256,8 +4256,8 @@
         </p:nvSpPr>
         <p:spPr>
           <a:xfrm>
-            <a:off x="960120" y="5321808"/>
-            <a:ext cx="4937760" cy="365760"/>
+            <a:off x="1143000" y="5824728"/>
+            <a:ext cx="4892040" cy="365760"/>
           </a:xfrm>
           <a:prstGeom prst="rect">
             <a:avLst/>
@@ -4281,7 +4281,7 @@
                 <a:ea typeface="Calibri" pitchFamily="34" charset="-122"/>
                 <a:cs typeface="Calibri" pitchFamily="34" charset="-120"/>
               </a:rPr>
-              <a:t>Full HFSS model</a:t>
+              <a:t>Full HFSS model (phantom, oil, tumor)</a:t>
             </a:r>
             <a:endParaRPr lang="en-US" sz="1300" dirty="0"/>
           </a:p>
@@ -4295,8 +4295,8 @@
         </p:nvSpPr>
         <p:spPr>
           <a:xfrm>
-            <a:off x="6263640" y="1645920"/>
-            <a:ext cx="4937760" cy="4069080"/>
+            <a:off x="6172200" y="1691640"/>
+            <a:ext cx="4892040" cy="4069080"/>
           </a:xfrm>
           <a:prstGeom prst="roundRect">
             <a:avLst>
@@ -4323,7 +4323,7 @@
       </p:sp>
       <p:pic>
         <p:nvPicPr>
-          <p:cNvPr id="8" name="Image 1" descr="setup_photos/sim_closeup.png">    </p:cNvPr>
+          <p:cNvPr id="8" name="Image 1" descr="setup_photos/SimulatedImage02.png">    </p:cNvPr>
           <p:cNvPicPr>
             <a:picLocks noChangeAspect="1"/>
           </p:cNvPicPr>
@@ -4337,8 +4337,8 @@
         </p:blipFill>
         <p:spPr>
           <a:xfrm>
-            <a:off x="6355080" y="1737360"/>
-            <a:ext cx="4754880" cy="3566160"/>
+            <a:off x="6263640" y="1783080"/>
+            <a:ext cx="4709160" cy="3566160"/>
           </a:xfrm>
           <a:prstGeom prst="rect">
             <a:avLst/>
@@ -4353,8 +4353,8 @@
         </p:nvSpPr>
         <p:spPr>
           <a:xfrm>
-            <a:off x="6263640" y="5321808"/>
-            <a:ext cx="4937760" cy="365760"/>
+            <a:off x="6172200" y="5367528"/>
+            <a:ext cx="4892040" cy="365760"/>
           </a:xfrm>
           <a:prstGeom prst="rect">
             <a:avLst/>
@@ -4378,48 +4378,9 @@
                 <a:ea typeface="Calibri" pitchFamily="34" charset="-122"/>
                 <a:cs typeface="Calibri" pitchFamily="34" charset="-120"/>
               </a:rPr>
-              <a:t>Antennas + tumor closeup</a:t>
+              <a:t>Antennas around the phantom bowl</a:t>
             </a:r>
             <a:endParaRPr lang="en-US" sz="1300" dirty="0"/>
-          </a:p>
-        </p:txBody>
-      </p:sp>
-      <p:sp>
-        <p:nvSpPr>
-          <p:cNvPr id="10" name="Text 6"/>
-          <p:cNvSpPr/>
-          <p:nvPr/>
-        </p:nvSpPr>
-        <p:spPr>
-          <a:xfrm>
-            <a:off x="548640" y="5532120"/>
-            <a:ext cx="11091672" cy="457200"/>
-          </a:xfrm>
-          <a:prstGeom prst="rect">
-            <a:avLst/>
-          </a:prstGeom>
-          <a:noFill/>
-          <a:ln/>
-        </p:spPr>
-        <p:txBody>
-          <a:bodyPr wrap="square" lIns="0" tIns="0" rIns="0" bIns="0" rtlCol="0" anchor="ctr"/>
-          <a:lstStyle/>
-          <a:p>
-            <a:pPr algn="ctr" indent="0" marL="0">
-              <a:buNone/>
-            </a:pPr>
-            <a:r>
-              <a:rPr lang="en-US" sz="1250" i="1" dirty="0">
-                <a:solidFill>
-                  <a:srgbClr val="836A68"/>
-                </a:solidFill>
-                <a:latin typeface="Calibri" pitchFamily="34" charset="0"/>
-                <a:ea typeface="Calibri" pitchFamily="34" charset="-122"/>
-                <a:cs typeface="Calibri" pitchFamily="34" charset="-120"/>
-              </a:rPr>
-              <a:t>Replace the placeholders in regression_deck/setup_photos/ (sim_model.*, sim_closeup.*) with real HFSS screenshots.</a:t>
-            </a:r>
-            <a:endParaRPr lang="en-US" sz="1250" dirty="0"/>
           </a:p>
         </p:txBody>
       </p:sp>

</xml_diff>